<commit_message>
Correct Team 3 and link Weeks 1-9 logs
</commit_message>
<xml_diff>
--- a/DSV_PROJECT/Final_Presentation.pptx
+++ b/DSV_PROJECT/Final_Presentation.pptx
@@ -2,49 +2,49 @@
 <file path=ppt/presentation.xml><?xml version="1.0" encoding="utf-8"?>
 <p:presentation xmlns:p="http://schemas.openxmlformats.org/presentationml/2006/main" embedTrueTypeFonts="1" saveSubsetFonts="1">
   <p:sldMasterIdLst>
-    <p:sldMasterId xmlns:r="http://schemas.openxmlformats.org/officeDocument/2006/relationships" id="2147483648" r:id="R06d81ad1d45c4264"/>
+    <p:sldMasterId xmlns:r="http://schemas.openxmlformats.org/officeDocument/2006/relationships" id="2147483648" r:id="R84f4c7dd9a84465f"/>
   </p:sldMasterIdLst>
   <p:notesMasterIdLst>
-    <p:notesMasterId xmlns:r="http://schemas.openxmlformats.org/officeDocument/2006/relationships" r:id="Raabde2584dd94326"/>
+    <p:notesMasterId xmlns:r="http://schemas.openxmlformats.org/officeDocument/2006/relationships" r:id="Rc366101e48ad485e"/>
   </p:notesMasterIdLst>
   <p:sldIdLst>
-    <p:sldId xmlns:r="http://schemas.openxmlformats.org/officeDocument/2006/relationships" id="256" r:id="Rf727585d9a634049"/>
-    <p:sldId xmlns:r="http://schemas.openxmlformats.org/officeDocument/2006/relationships" id="257" r:id="R396c30949dd848d9"/>
-    <p:sldId xmlns:r="http://schemas.openxmlformats.org/officeDocument/2006/relationships" id="258" r:id="R9bf9240aa1654d49"/>
-    <p:sldId xmlns:r="http://schemas.openxmlformats.org/officeDocument/2006/relationships" id="259" r:id="R9ad120a2a47c4bf2"/>
-    <p:sldId xmlns:r="http://schemas.openxmlformats.org/officeDocument/2006/relationships" id="260" r:id="Re5c2bd3416854edd"/>
-    <p:sldId xmlns:r="http://schemas.openxmlformats.org/officeDocument/2006/relationships" id="261" r:id="R9030076b808c4aa6"/>
-    <p:sldId xmlns:r="http://schemas.openxmlformats.org/officeDocument/2006/relationships" id="262" r:id="Ree9eca0fc8f44903"/>
-    <p:sldId xmlns:r="http://schemas.openxmlformats.org/officeDocument/2006/relationships" id="263" r:id="R28321d2c38c54b15"/>
-    <p:sldId xmlns:r="http://schemas.openxmlformats.org/officeDocument/2006/relationships" id="264" r:id="Re293e6ca131548d1"/>
-    <p:sldId xmlns:r="http://schemas.openxmlformats.org/officeDocument/2006/relationships" id="265" r:id="R23d31ffd0d044c1c"/>
-    <p:sldId xmlns:r="http://schemas.openxmlformats.org/officeDocument/2006/relationships" id="266" r:id="Rfbd78f5066564433"/>
-    <p:sldId xmlns:r="http://schemas.openxmlformats.org/officeDocument/2006/relationships" id="267" r:id="R354ac461fd8e4e08"/>
-    <p:sldId xmlns:r="http://schemas.openxmlformats.org/officeDocument/2006/relationships" id="268" r:id="Raeab5b9824cd4c94"/>
+    <p:sldId xmlns:r="http://schemas.openxmlformats.org/officeDocument/2006/relationships" id="256" r:id="Rdf945636685e4afb"/>
+    <p:sldId xmlns:r="http://schemas.openxmlformats.org/officeDocument/2006/relationships" id="257" r:id="R59493cc6c9a5410b"/>
+    <p:sldId xmlns:r="http://schemas.openxmlformats.org/officeDocument/2006/relationships" id="258" r:id="R3a23ac034a14462d"/>
+    <p:sldId xmlns:r="http://schemas.openxmlformats.org/officeDocument/2006/relationships" id="259" r:id="Rccbf27375eeb44cc"/>
+    <p:sldId xmlns:r="http://schemas.openxmlformats.org/officeDocument/2006/relationships" id="260" r:id="R813455a717fa4b02"/>
+    <p:sldId xmlns:r="http://schemas.openxmlformats.org/officeDocument/2006/relationships" id="261" r:id="R19498805cdeb4439"/>
+    <p:sldId xmlns:r="http://schemas.openxmlformats.org/officeDocument/2006/relationships" id="262" r:id="R8d0dcf17e83d438b"/>
+    <p:sldId xmlns:r="http://schemas.openxmlformats.org/officeDocument/2006/relationships" id="263" r:id="R62200b1601e54df8"/>
+    <p:sldId xmlns:r="http://schemas.openxmlformats.org/officeDocument/2006/relationships" id="264" r:id="R8cc9bb3479ac4249"/>
+    <p:sldId xmlns:r="http://schemas.openxmlformats.org/officeDocument/2006/relationships" id="265" r:id="Rd1782433d88f4888"/>
+    <p:sldId xmlns:r="http://schemas.openxmlformats.org/officeDocument/2006/relationships" id="266" r:id="Rd5d1695b7d074c04"/>
+    <p:sldId xmlns:r="http://schemas.openxmlformats.org/officeDocument/2006/relationships" id="267" r:id="R0b824547578d4897"/>
+    <p:sldId xmlns:r="http://schemas.openxmlformats.org/officeDocument/2006/relationships" id="268" r:id="R9d064c72cbef4b4e"/>
   </p:sldIdLst>
   <p:sldSz cx="18288000" cy="10287000"/>
   <p:notesSz cx="6858000" cy="9144000"/>
   <p:embeddedFontLst>
     <p:embeddedFont>
       <p:font typeface="Poppins"/>
-      <p:regular xmlns:r="http://schemas.openxmlformats.org/officeDocument/2006/relationships" r:id="R9b80f257e65f4406"/>
+      <p:regular xmlns:r="http://schemas.openxmlformats.org/officeDocument/2006/relationships" r:id="R2a0523ab989f406f"/>
     </p:embeddedFont>
     <p:embeddedFont>
       <p:font typeface="Poppins Bold"/>
-      <p:regular xmlns:r="http://schemas.openxmlformats.org/officeDocument/2006/relationships" r:id="Re9aac4249be74876"/>
-      <p:bold xmlns:r="http://schemas.openxmlformats.org/officeDocument/2006/relationships" r:id="Rd32e3ce41e754dc1"/>
+      <p:regular xmlns:r="http://schemas.openxmlformats.org/officeDocument/2006/relationships" r:id="R6475f9d253704112"/>
+      <p:bold xmlns:r="http://schemas.openxmlformats.org/officeDocument/2006/relationships" r:id="R38dbc5176455409d"/>
     </p:embeddedFont>
     <p:embeddedFont>
       <p:font typeface="Poppins Bold Italics"/>
-      <p:regular xmlns:r="http://schemas.openxmlformats.org/officeDocument/2006/relationships" r:id="R6e785a30082043f0"/>
+      <p:regular xmlns:r="http://schemas.openxmlformats.org/officeDocument/2006/relationships" r:id="R2b01c24d574443c7"/>
     </p:embeddedFont>
     <p:embeddedFont>
       <p:font typeface="Poppins Italics"/>
-      <p:regular xmlns:r="http://schemas.openxmlformats.org/officeDocument/2006/relationships" r:id="R841e3afcd7d34370"/>
+      <p:regular xmlns:r="http://schemas.openxmlformats.org/officeDocument/2006/relationships" r:id="Rf80252be4f4f4c27"/>
     </p:embeddedFont>
     <p:embeddedFont>
       <p:font typeface="Times New Roman Bold"/>
-      <p:bold xmlns:r="http://schemas.openxmlformats.org/officeDocument/2006/relationships" r:id="R4cf0361d921e4524"/>
+      <p:bold xmlns:r="http://schemas.openxmlformats.org/officeDocument/2006/relationships" r:id="R373afb0697f74cdb"/>
     </p:embeddedFont>
   </p:embeddedFontLst>
 </p:presentation>
@@ -502,7 +502,7 @@
           <a:lstStyle xmlns:a="http://schemas.openxmlformats.org/drawingml/2006/main"/>
           <a:p xmlns:a="http://schemas.openxmlformats.org/drawingml/2006/main">
             <a:r>
-              <a:t>Team No. 4. Completed Weeks 1–9 code and review materials. Actual expo and viva attendance remain team activities. PCA is unsupervised; no attrition classifier is claimed.</a:t>
+              <a:t>Team No. 3. Completed Weeks 1–9 code and review materials. Actual expo and viva attendance remain team activities. PCA is unsupervised; no attrition classifier is claimed.</a:t>
             </a:r>
           </a:p>
         </p:txBody>
@@ -572,7 +572,7 @@
           <a:lstStyle xmlns:a="http://schemas.openxmlformats.org/drawingml/2006/main"/>
           <a:p xmlns:a="http://schemas.openxmlformats.org/drawingml/2006/main">
             <a:r>
-              <a:t>Member names and previously stated roles come from the earlier Week 2 team log, confirmed by the user for Team No. 4. Exact allocation of notebook commits should be verified with members.</a:t>
+              <a:t>Member names and previously stated roles come from the earlier Week 2 team log, confirmed by the user for Team No. 3. Exact allocation of notebook commits should be verified with members.</a:t>
             </a:r>
           </a:p>
         </p:txBody>
@@ -1399,7 +1399,7 @@
           <p:cNvPr id="2" name="Title 1">
             <a:extLst xmlns:a="http://schemas.openxmlformats.org/drawingml/2006/main">
               <a:ext uri="{FF2B5EF4-FFF2-40B4-BE49-F238E27FC236}">
-                <a16:creationId xmlns:a16="http://schemas.microsoft.com/office/drawing/2014/main" id="{2622DD95-C02F-4DD6-B988-3DC518355904}"/>
+                <a16:creationId xmlns:a16="http://schemas.microsoft.com/office/drawing/2014/main" id="{05FEA639-E2DB-44D6-A992-8A9F9A3F7577}"/>
               </a:ext>
             </a:extLst>
           </p:cNvPr>
@@ -1431,7 +1431,7 @@
           <p:cNvPr id="3" name="Subtitle 2">
             <a:extLst xmlns:a="http://schemas.openxmlformats.org/drawingml/2006/main">
               <a:ext uri="{FF2B5EF4-FFF2-40B4-BE49-F238E27FC236}">
-                <a16:creationId xmlns:a16="http://schemas.microsoft.com/office/drawing/2014/main" id="{2B5183C9-71D1-460E-84A9-B4715E17B271}"/>
+                <a16:creationId xmlns:a16="http://schemas.microsoft.com/office/drawing/2014/main" id="{26C7EC9D-FEE5-4487-A899-439D340A4AE8}"/>
               </a:ext>
             </a:extLst>
           </p:cNvPr>
@@ -1554,7 +1554,7 @@
           <p:cNvPr id="4" name="Date Placeholder 3">
             <a:extLst xmlns:a="http://schemas.openxmlformats.org/drawingml/2006/main">
               <a:ext uri="{FF2B5EF4-FFF2-40B4-BE49-F238E27FC236}">
-                <a16:creationId xmlns:a16="http://schemas.microsoft.com/office/drawing/2014/main" id="{AAB4010C-EF68-46D7-B87A-DF0A833B2AA7}"/>
+                <a16:creationId xmlns:a16="http://schemas.microsoft.com/office/drawing/2014/main" id="{9A255D00-00CC-4338-BA92-736A8E11245F}"/>
               </a:ext>
             </a:extLst>
           </p:cNvPr>
@@ -1582,7 +1582,7 @@
           <p:cNvPr id="5" name="Footer Placeholder 4">
             <a:extLst xmlns:a="http://schemas.openxmlformats.org/drawingml/2006/main">
               <a:ext uri="{FF2B5EF4-FFF2-40B4-BE49-F238E27FC236}">
-                <a16:creationId xmlns:a16="http://schemas.microsoft.com/office/drawing/2014/main" id="{58351165-F8CC-4C54-9BF1-6118D56E1AA4}"/>
+                <a16:creationId xmlns:a16="http://schemas.microsoft.com/office/drawing/2014/main" id="{F22BF5F1-87E1-4CBA-98BB-A20801D1F125}"/>
               </a:ext>
             </a:extLst>
           </p:cNvPr>
@@ -1607,7 +1607,7 @@
           <p:cNvPr id="6" name="Slide Number Placeholder 5">
             <a:extLst xmlns:a="http://schemas.openxmlformats.org/drawingml/2006/main">
               <a:ext uri="{FF2B5EF4-FFF2-40B4-BE49-F238E27FC236}">
-                <a16:creationId xmlns:a16="http://schemas.microsoft.com/office/drawing/2014/main" id="{A94964A6-0E30-4390-B8B3-B0E855B777A9}"/>
+                <a16:creationId xmlns:a16="http://schemas.microsoft.com/office/drawing/2014/main" id="{B56C115C-6E34-4575-9DD8-FA93414149D0}"/>
               </a:ext>
             </a:extLst>
           </p:cNvPr>
@@ -1652,7 +1652,7 @@
           <p:cNvPr id="2" name="Title 1">
             <a:extLst xmlns:a="http://schemas.openxmlformats.org/drawingml/2006/main">
               <a:ext uri="{FF2B5EF4-FFF2-40B4-BE49-F238E27FC236}">
-                <a16:creationId xmlns:a16="http://schemas.microsoft.com/office/drawing/2014/main" id="{D078E895-13B5-4380-84B9-7AF2810AC213}"/>
+                <a16:creationId xmlns:a16="http://schemas.microsoft.com/office/drawing/2014/main" id="{37BA706F-EF1E-4183-A5D4-C7D872550094}"/>
               </a:ext>
             </a:extLst>
           </p:cNvPr>
@@ -1679,7 +1679,7 @@
           <p:cNvPr id="3" name="Vertical Text Placeholder 2">
             <a:extLst xmlns:a="http://schemas.openxmlformats.org/drawingml/2006/main">
               <a:ext uri="{FF2B5EF4-FFF2-40B4-BE49-F238E27FC236}">
-                <a16:creationId xmlns:a16="http://schemas.microsoft.com/office/drawing/2014/main" id="{58913F03-76DC-4229-BB6A-9FAFC93CA039}"/>
+                <a16:creationId xmlns:a16="http://schemas.microsoft.com/office/drawing/2014/main" id="{0AF01C83-C5C8-4572-92EB-08CAD0C1317E}"/>
               </a:ext>
             </a:extLst>
           </p:cNvPr>
@@ -1741,7 +1741,7 @@
           <p:cNvPr id="4" name="Date Placeholder 3">
             <a:extLst xmlns:a="http://schemas.openxmlformats.org/drawingml/2006/main">
               <a:ext uri="{FF2B5EF4-FFF2-40B4-BE49-F238E27FC236}">
-                <a16:creationId xmlns:a16="http://schemas.microsoft.com/office/drawing/2014/main" id="{03A1F457-BB81-426F-8B6B-0F9FD6C2D7DB}"/>
+                <a16:creationId xmlns:a16="http://schemas.microsoft.com/office/drawing/2014/main" id="{ECAF25BF-A475-4C66-93A0-03BAD9601E44}"/>
               </a:ext>
             </a:extLst>
           </p:cNvPr>
@@ -1769,7 +1769,7 @@
           <p:cNvPr id="5" name="Footer Placeholder 4">
             <a:extLst xmlns:a="http://schemas.openxmlformats.org/drawingml/2006/main">
               <a:ext uri="{FF2B5EF4-FFF2-40B4-BE49-F238E27FC236}">
-                <a16:creationId xmlns:a16="http://schemas.microsoft.com/office/drawing/2014/main" id="{640E154E-610F-44F9-A52D-778DC0851EE9}"/>
+                <a16:creationId xmlns:a16="http://schemas.microsoft.com/office/drawing/2014/main" id="{646B0600-C72D-46E7-ADBA-38D1A8788C97}"/>
               </a:ext>
             </a:extLst>
           </p:cNvPr>
@@ -1794,7 +1794,7 @@
           <p:cNvPr id="6" name="Slide Number Placeholder 5">
             <a:extLst xmlns:a="http://schemas.openxmlformats.org/drawingml/2006/main">
               <a:ext uri="{FF2B5EF4-FFF2-40B4-BE49-F238E27FC236}">
-                <a16:creationId xmlns:a16="http://schemas.microsoft.com/office/drawing/2014/main" id="{7F33D7A9-6B89-4FED-8339-7ABD9E064E41}"/>
+                <a16:creationId xmlns:a16="http://schemas.microsoft.com/office/drawing/2014/main" id="{D3B6E342-593F-4DDA-B0A5-49E6FE6AEDB2}"/>
               </a:ext>
             </a:extLst>
           </p:cNvPr>
@@ -1839,7 +1839,7 @@
           <p:cNvPr id="2" name="Vertical Title 1">
             <a:extLst xmlns:a="http://schemas.openxmlformats.org/drawingml/2006/main">
               <a:ext uri="{FF2B5EF4-FFF2-40B4-BE49-F238E27FC236}">
-                <a16:creationId xmlns:a16="http://schemas.microsoft.com/office/drawing/2014/main" id="{D274E2EF-1544-427E-84AD-1EDD021E59D0}"/>
+                <a16:creationId xmlns:a16="http://schemas.microsoft.com/office/drawing/2014/main" id="{628D88FE-374C-4288-A664-BF4E707264E0}"/>
               </a:ext>
             </a:extLst>
           </p:cNvPr>
@@ -1871,7 +1871,7 @@
           <p:cNvPr id="3" name="Vertical Text Placeholder 2">
             <a:extLst xmlns:a="http://schemas.openxmlformats.org/drawingml/2006/main">
               <a:ext uri="{FF2B5EF4-FFF2-40B4-BE49-F238E27FC236}">
-                <a16:creationId xmlns:a16="http://schemas.microsoft.com/office/drawing/2014/main" id="{25B18FE1-F241-4BC1-873A-085BE5CF20CA}"/>
+                <a16:creationId xmlns:a16="http://schemas.microsoft.com/office/drawing/2014/main" id="{3FAFE04D-EABD-4D3F-A4A0-8B31327AA21F}"/>
               </a:ext>
             </a:extLst>
           </p:cNvPr>
@@ -1938,7 +1938,7 @@
           <p:cNvPr id="4" name="Date Placeholder 3">
             <a:extLst xmlns:a="http://schemas.openxmlformats.org/drawingml/2006/main">
               <a:ext uri="{FF2B5EF4-FFF2-40B4-BE49-F238E27FC236}">
-                <a16:creationId xmlns:a16="http://schemas.microsoft.com/office/drawing/2014/main" id="{B81B4648-E155-47E5-8C9E-0D2836F3D508}"/>
+                <a16:creationId xmlns:a16="http://schemas.microsoft.com/office/drawing/2014/main" id="{58AACAB9-BE61-44CF-B0A3-967A20DDBBD1}"/>
               </a:ext>
             </a:extLst>
           </p:cNvPr>
@@ -1966,7 +1966,7 @@
           <p:cNvPr id="5" name="Footer Placeholder 4">
             <a:extLst xmlns:a="http://schemas.openxmlformats.org/drawingml/2006/main">
               <a:ext uri="{FF2B5EF4-FFF2-40B4-BE49-F238E27FC236}">
-                <a16:creationId xmlns:a16="http://schemas.microsoft.com/office/drawing/2014/main" id="{8CE58354-76FC-4566-AF8F-C78D28713022}"/>
+                <a16:creationId xmlns:a16="http://schemas.microsoft.com/office/drawing/2014/main" id="{23223139-6002-4B66-A65D-42CE6A547DAC}"/>
               </a:ext>
             </a:extLst>
           </p:cNvPr>
@@ -1991,7 +1991,7 @@
           <p:cNvPr id="6" name="Slide Number Placeholder 5">
             <a:extLst xmlns:a="http://schemas.openxmlformats.org/drawingml/2006/main">
               <a:ext uri="{FF2B5EF4-FFF2-40B4-BE49-F238E27FC236}">
-                <a16:creationId xmlns:a16="http://schemas.microsoft.com/office/drawing/2014/main" id="{6EA1372E-BFF7-4EEE-88F2-F69B4F7F64D7}"/>
+                <a16:creationId xmlns:a16="http://schemas.microsoft.com/office/drawing/2014/main" id="{D8137850-4761-4D0A-B9F1-5162BF60E09D}"/>
               </a:ext>
             </a:extLst>
           </p:cNvPr>
@@ -2036,7 +2036,7 @@
           <p:cNvPr id="2" name="Title 1">
             <a:extLst xmlns:a="http://schemas.openxmlformats.org/drawingml/2006/main">
               <a:ext uri="{FF2B5EF4-FFF2-40B4-BE49-F238E27FC236}">
-                <a16:creationId xmlns:a16="http://schemas.microsoft.com/office/drawing/2014/main" id="{FCA223BC-3A2F-4290-AF27-BE103665A166}"/>
+                <a16:creationId xmlns:a16="http://schemas.microsoft.com/office/drawing/2014/main" id="{00BC2FB8-5DBB-45CC-A5ED-D75988FFFA1C}"/>
               </a:ext>
             </a:extLst>
           </p:cNvPr>
@@ -2063,7 +2063,7 @@
           <p:cNvPr id="3" name="Content Placeholder 2">
             <a:extLst xmlns:a="http://schemas.openxmlformats.org/drawingml/2006/main">
               <a:ext uri="{FF2B5EF4-FFF2-40B4-BE49-F238E27FC236}">
-                <a16:creationId xmlns:a16="http://schemas.microsoft.com/office/drawing/2014/main" id="{DB994E91-6A0B-495A-B516-D38889B14B2C}"/>
+                <a16:creationId xmlns:a16="http://schemas.microsoft.com/office/drawing/2014/main" id="{AA1310D0-B5AA-48AB-A8FA-1EE3D3DF4CAD}"/>
               </a:ext>
             </a:extLst>
           </p:cNvPr>
@@ -2125,7 +2125,7 @@
           <p:cNvPr id="4" name="Date Placeholder 3">
             <a:extLst xmlns:a="http://schemas.openxmlformats.org/drawingml/2006/main">
               <a:ext uri="{FF2B5EF4-FFF2-40B4-BE49-F238E27FC236}">
-                <a16:creationId xmlns:a16="http://schemas.microsoft.com/office/drawing/2014/main" id="{7B527242-8EB5-4E82-9824-1305FD3ADCB9}"/>
+                <a16:creationId xmlns:a16="http://schemas.microsoft.com/office/drawing/2014/main" id="{318D3FA5-F622-4E68-806C-5C161731463F}"/>
               </a:ext>
             </a:extLst>
           </p:cNvPr>
@@ -2153,7 +2153,7 @@
           <p:cNvPr id="5" name="Footer Placeholder 4">
             <a:extLst xmlns:a="http://schemas.openxmlformats.org/drawingml/2006/main">
               <a:ext uri="{FF2B5EF4-FFF2-40B4-BE49-F238E27FC236}">
-                <a16:creationId xmlns:a16="http://schemas.microsoft.com/office/drawing/2014/main" id="{76EAADC4-FB9B-4DFB-836C-797865437471}"/>
+                <a16:creationId xmlns:a16="http://schemas.microsoft.com/office/drawing/2014/main" id="{E04EDD9F-4D4D-4A04-9D18-14E77E43B3C1}"/>
               </a:ext>
             </a:extLst>
           </p:cNvPr>
@@ -2178,7 +2178,7 @@
           <p:cNvPr id="6" name="Slide Number Placeholder 5">
             <a:extLst xmlns:a="http://schemas.openxmlformats.org/drawingml/2006/main">
               <a:ext uri="{FF2B5EF4-FFF2-40B4-BE49-F238E27FC236}">
-                <a16:creationId xmlns:a16="http://schemas.microsoft.com/office/drawing/2014/main" id="{20B4B21F-E354-4C3C-AEF5-37BDC387E80C}"/>
+                <a16:creationId xmlns:a16="http://schemas.microsoft.com/office/drawing/2014/main" id="{3505FBC6-6892-4C29-8030-739099068F9B}"/>
               </a:ext>
             </a:extLst>
           </p:cNvPr>
@@ -2223,7 +2223,7 @@
           <p:cNvPr id="2" name="Title 1">
             <a:extLst xmlns:a="http://schemas.openxmlformats.org/drawingml/2006/main">
               <a:ext uri="{FF2B5EF4-FFF2-40B4-BE49-F238E27FC236}">
-                <a16:creationId xmlns:a16="http://schemas.microsoft.com/office/drawing/2014/main" id="{6DEC6E26-4603-479C-AAE1-8B85E5E44703}"/>
+                <a16:creationId xmlns:a16="http://schemas.microsoft.com/office/drawing/2014/main" id="{59EB0E60-087A-49F7-A32D-0E2C1B1A1CE3}"/>
               </a:ext>
             </a:extLst>
           </p:cNvPr>
@@ -2260,7 +2260,7 @@
           <p:cNvPr id="3" name="Text Placeholder 2">
             <a:extLst xmlns:a="http://schemas.openxmlformats.org/drawingml/2006/main">
               <a:ext uri="{FF2B5EF4-FFF2-40B4-BE49-F238E27FC236}">
-                <a16:creationId xmlns:a16="http://schemas.microsoft.com/office/drawing/2014/main" id="{9ACBA5DC-E29A-494C-8299-A04E4500CDF3}"/>
+                <a16:creationId xmlns:a16="http://schemas.microsoft.com/office/drawing/2014/main" id="{7A56BA80-E295-4602-AF47-1A2E5484C9D6}"/>
               </a:ext>
             </a:extLst>
           </p:cNvPr>
@@ -2386,7 +2386,7 @@
           <p:cNvPr id="4" name="Date Placeholder 3">
             <a:extLst xmlns:a="http://schemas.openxmlformats.org/drawingml/2006/main">
               <a:ext uri="{FF2B5EF4-FFF2-40B4-BE49-F238E27FC236}">
-                <a16:creationId xmlns:a16="http://schemas.microsoft.com/office/drawing/2014/main" id="{E16DBD3F-44DC-413C-99AD-165322C6AABF}"/>
+                <a16:creationId xmlns:a16="http://schemas.microsoft.com/office/drawing/2014/main" id="{88C3BE7C-CC32-4003-B615-B7BD657F8200}"/>
               </a:ext>
             </a:extLst>
           </p:cNvPr>
@@ -2414,7 +2414,7 @@
           <p:cNvPr id="5" name="Footer Placeholder 4">
             <a:extLst xmlns:a="http://schemas.openxmlformats.org/drawingml/2006/main">
               <a:ext uri="{FF2B5EF4-FFF2-40B4-BE49-F238E27FC236}">
-                <a16:creationId xmlns:a16="http://schemas.microsoft.com/office/drawing/2014/main" id="{40234CAA-0AB1-4234-B882-CBE0FB553707}"/>
+                <a16:creationId xmlns:a16="http://schemas.microsoft.com/office/drawing/2014/main" id="{FDD8B215-429F-4704-BC04-AB4AED8F439D}"/>
               </a:ext>
             </a:extLst>
           </p:cNvPr>
@@ -2439,7 +2439,7 @@
           <p:cNvPr id="6" name="Slide Number Placeholder 5">
             <a:extLst xmlns:a="http://schemas.openxmlformats.org/drawingml/2006/main">
               <a:ext uri="{FF2B5EF4-FFF2-40B4-BE49-F238E27FC236}">
-                <a16:creationId xmlns:a16="http://schemas.microsoft.com/office/drawing/2014/main" id="{57745F11-B6D2-496F-AC7E-2F8A04B429E7}"/>
+                <a16:creationId xmlns:a16="http://schemas.microsoft.com/office/drawing/2014/main" id="{266705CB-817E-42FF-87FE-55531BF5D765}"/>
               </a:ext>
             </a:extLst>
           </p:cNvPr>
@@ -2484,7 +2484,7 @@
           <p:cNvPr id="2" name="Title 1">
             <a:extLst xmlns:a="http://schemas.openxmlformats.org/drawingml/2006/main">
               <a:ext uri="{FF2B5EF4-FFF2-40B4-BE49-F238E27FC236}">
-                <a16:creationId xmlns:a16="http://schemas.microsoft.com/office/drawing/2014/main" id="{D1F2E8C7-1EDA-40D8-A01A-8AB58C11BB5E}"/>
+                <a16:creationId xmlns:a16="http://schemas.microsoft.com/office/drawing/2014/main" id="{CE023FB0-F3BD-4AAF-8F53-F478B79548F6}"/>
               </a:ext>
             </a:extLst>
           </p:cNvPr>
@@ -2511,7 +2511,7 @@
           <p:cNvPr id="3" name="Content Placeholder 2">
             <a:extLst xmlns:a="http://schemas.openxmlformats.org/drawingml/2006/main">
               <a:ext uri="{FF2B5EF4-FFF2-40B4-BE49-F238E27FC236}">
-                <a16:creationId xmlns:a16="http://schemas.microsoft.com/office/drawing/2014/main" id="{9B42BD34-11C2-4E32-B074-1E1CCE7EAD72}"/>
+                <a16:creationId xmlns:a16="http://schemas.microsoft.com/office/drawing/2014/main" id="{B01B9926-A98E-4D46-8ABF-9964267B2370}"/>
               </a:ext>
             </a:extLst>
           </p:cNvPr>
@@ -2615,7 +2615,7 @@
           <p:cNvPr id="4" name="Content Placeholder 3">
             <a:extLst xmlns:a="http://schemas.openxmlformats.org/drawingml/2006/main">
               <a:ext uri="{FF2B5EF4-FFF2-40B4-BE49-F238E27FC236}">
-                <a16:creationId xmlns:a16="http://schemas.microsoft.com/office/drawing/2014/main" id="{693CE509-1BA6-4568-B8FC-560BE182A2F6}"/>
+                <a16:creationId xmlns:a16="http://schemas.microsoft.com/office/drawing/2014/main" id="{95DC8AC2-1F9B-4811-AD5D-89199CA8F9D7}"/>
               </a:ext>
             </a:extLst>
           </p:cNvPr>
@@ -2719,7 +2719,7 @@
           <p:cNvPr id="5" name="Date Placeholder 4">
             <a:extLst xmlns:a="http://schemas.openxmlformats.org/drawingml/2006/main">
               <a:ext uri="{FF2B5EF4-FFF2-40B4-BE49-F238E27FC236}">
-                <a16:creationId xmlns:a16="http://schemas.microsoft.com/office/drawing/2014/main" id="{F798B7E0-5A0B-41E6-8881-217D4E673432}"/>
+                <a16:creationId xmlns:a16="http://schemas.microsoft.com/office/drawing/2014/main" id="{6642907E-74E9-4A31-9B88-CD0D62F6AB61}"/>
               </a:ext>
             </a:extLst>
           </p:cNvPr>
@@ -2747,7 +2747,7 @@
           <p:cNvPr id="6" name="Footer Placeholder 5">
             <a:extLst xmlns:a="http://schemas.openxmlformats.org/drawingml/2006/main">
               <a:ext uri="{FF2B5EF4-FFF2-40B4-BE49-F238E27FC236}">
-                <a16:creationId xmlns:a16="http://schemas.microsoft.com/office/drawing/2014/main" id="{1EFAC542-1278-4B50-9404-6A6A9771C3C7}"/>
+                <a16:creationId xmlns:a16="http://schemas.microsoft.com/office/drawing/2014/main" id="{D14DCFA8-62C6-4F07-807E-31F249AABD49}"/>
               </a:ext>
             </a:extLst>
           </p:cNvPr>
@@ -2772,7 +2772,7 @@
           <p:cNvPr id="7" name="Slide Number Placeholder 6">
             <a:extLst xmlns:a="http://schemas.openxmlformats.org/drawingml/2006/main">
               <a:ext uri="{FF2B5EF4-FFF2-40B4-BE49-F238E27FC236}">
-                <a16:creationId xmlns:a16="http://schemas.microsoft.com/office/drawing/2014/main" id="{FA4D53D1-7481-4274-853A-8B534BFE454F}"/>
+                <a16:creationId xmlns:a16="http://schemas.microsoft.com/office/drawing/2014/main" id="{93B4F9B0-758B-4373-BEAD-26F114B489AE}"/>
               </a:ext>
             </a:extLst>
           </p:cNvPr>
@@ -2817,7 +2817,7 @@
           <p:cNvPr id="2" name="Title 1">
             <a:extLst xmlns:a="http://schemas.openxmlformats.org/drawingml/2006/main">
               <a:ext uri="{FF2B5EF4-FFF2-40B4-BE49-F238E27FC236}">
-                <a16:creationId xmlns:a16="http://schemas.microsoft.com/office/drawing/2014/main" id="{B8253B8B-6A9F-4729-BCBD-BB0BD49EF0D5}"/>
+                <a16:creationId xmlns:a16="http://schemas.microsoft.com/office/drawing/2014/main" id="{9662CB6C-1533-4FE4-B796-CFD8B9016C8F}"/>
               </a:ext>
             </a:extLst>
           </p:cNvPr>
@@ -2849,7 +2849,7 @@
           <p:cNvPr id="3" name="Text Placeholder 2">
             <a:extLst xmlns:a="http://schemas.openxmlformats.org/drawingml/2006/main">
               <a:ext uri="{FF2B5EF4-FFF2-40B4-BE49-F238E27FC236}">
-                <a16:creationId xmlns:a16="http://schemas.microsoft.com/office/drawing/2014/main" id="{5F7E383F-F560-49CB-9BD1-5E39731C8F95}"/>
+                <a16:creationId xmlns:a16="http://schemas.microsoft.com/office/drawing/2014/main" id="{6BB407C4-D156-4FF3-BAB7-3BDC0D79CF0B}"/>
               </a:ext>
             </a:extLst>
           </p:cNvPr>
@@ -2921,7 +2921,7 @@
           <p:cNvPr id="4" name="Content Placeholder 3">
             <a:extLst xmlns:a="http://schemas.openxmlformats.org/drawingml/2006/main">
               <a:ext uri="{FF2B5EF4-FFF2-40B4-BE49-F238E27FC236}">
-                <a16:creationId xmlns:a16="http://schemas.microsoft.com/office/drawing/2014/main" id="{43C2F31A-CFCA-42D3-A1C8-D8DDF858A017}"/>
+                <a16:creationId xmlns:a16="http://schemas.microsoft.com/office/drawing/2014/main" id="{B3241D10-DCD3-4230-A552-93A5F3DA4FA1}"/>
               </a:ext>
             </a:extLst>
           </p:cNvPr>
@@ -3025,7 +3025,7 @@
           <p:cNvPr id="5" name="Text Placeholder 4">
             <a:extLst xmlns:a="http://schemas.openxmlformats.org/drawingml/2006/main">
               <a:ext uri="{FF2B5EF4-FFF2-40B4-BE49-F238E27FC236}">
-                <a16:creationId xmlns:a16="http://schemas.microsoft.com/office/drawing/2014/main" id="{AA2FF9CE-4506-4BA7-B01E-F634044410DA}"/>
+                <a16:creationId xmlns:a16="http://schemas.microsoft.com/office/drawing/2014/main" id="{F3971925-7331-40AD-8A31-206DD14B30AD}"/>
               </a:ext>
             </a:extLst>
           </p:cNvPr>
@@ -3097,7 +3097,7 @@
           <p:cNvPr id="6" name="Content Placeholder 5">
             <a:extLst xmlns:a="http://schemas.openxmlformats.org/drawingml/2006/main">
               <a:ext uri="{FF2B5EF4-FFF2-40B4-BE49-F238E27FC236}">
-                <a16:creationId xmlns:a16="http://schemas.microsoft.com/office/drawing/2014/main" id="{AA02F9D0-5410-4E3F-A89C-524817BA5D8C}"/>
+                <a16:creationId xmlns:a16="http://schemas.microsoft.com/office/drawing/2014/main" id="{95C968B9-12CF-4507-A592-4A55F2306D68}"/>
               </a:ext>
             </a:extLst>
           </p:cNvPr>
@@ -3201,7 +3201,7 @@
           <p:cNvPr id="7" name="Date Placeholder 6">
             <a:extLst xmlns:a="http://schemas.openxmlformats.org/drawingml/2006/main">
               <a:ext uri="{FF2B5EF4-FFF2-40B4-BE49-F238E27FC236}">
-                <a16:creationId xmlns:a16="http://schemas.microsoft.com/office/drawing/2014/main" id="{8BBE7A13-97A5-4782-AE24-50B368177B73}"/>
+                <a16:creationId xmlns:a16="http://schemas.microsoft.com/office/drawing/2014/main" id="{CEFD79DD-4425-4CF6-8A3C-755358838B0F}"/>
               </a:ext>
             </a:extLst>
           </p:cNvPr>
@@ -3229,7 +3229,7 @@
           <p:cNvPr id="8" name="Footer Placeholder 7">
             <a:extLst xmlns:a="http://schemas.openxmlformats.org/drawingml/2006/main">
               <a:ext uri="{FF2B5EF4-FFF2-40B4-BE49-F238E27FC236}">
-                <a16:creationId xmlns:a16="http://schemas.microsoft.com/office/drawing/2014/main" id="{8C07242E-1499-48C2-9623-1113D9B1B597}"/>
+                <a16:creationId xmlns:a16="http://schemas.microsoft.com/office/drawing/2014/main" id="{4C2171F2-EB86-4530-A52D-7F94084EDE4B}"/>
               </a:ext>
             </a:extLst>
           </p:cNvPr>
@@ -3254,7 +3254,7 @@
           <p:cNvPr id="9" name="Slide Number Placeholder 8">
             <a:extLst xmlns:a="http://schemas.openxmlformats.org/drawingml/2006/main">
               <a:ext uri="{FF2B5EF4-FFF2-40B4-BE49-F238E27FC236}">
-                <a16:creationId xmlns:a16="http://schemas.microsoft.com/office/drawing/2014/main" id="{F47A3E1E-B671-4781-BFB6-43BDC65608E2}"/>
+                <a16:creationId xmlns:a16="http://schemas.microsoft.com/office/drawing/2014/main" id="{05C67B4A-3A52-4EED-BBB2-4ABDE7177B22}"/>
               </a:ext>
             </a:extLst>
           </p:cNvPr>
@@ -3299,7 +3299,7 @@
           <p:cNvPr id="2" name="Title 1">
             <a:extLst xmlns:a="http://schemas.openxmlformats.org/drawingml/2006/main">
               <a:ext uri="{FF2B5EF4-FFF2-40B4-BE49-F238E27FC236}">
-                <a16:creationId xmlns:a16="http://schemas.microsoft.com/office/drawing/2014/main" id="{56596529-0225-4681-96ED-B5776A3B97BC}"/>
+                <a16:creationId xmlns:a16="http://schemas.microsoft.com/office/drawing/2014/main" id="{530D9B85-37C2-4CF2-A7EB-B01D5F3E2F42}"/>
               </a:ext>
             </a:extLst>
           </p:cNvPr>
@@ -3326,7 +3326,7 @@
           <p:cNvPr id="3" name="Date Placeholder 2">
             <a:extLst xmlns:a="http://schemas.openxmlformats.org/drawingml/2006/main">
               <a:ext uri="{FF2B5EF4-FFF2-40B4-BE49-F238E27FC236}">
-                <a16:creationId xmlns:a16="http://schemas.microsoft.com/office/drawing/2014/main" id="{5CFEE44B-B07B-4A96-89AE-9B34C504715B}"/>
+                <a16:creationId xmlns:a16="http://schemas.microsoft.com/office/drawing/2014/main" id="{9AB26FE0-0E66-4DBE-8459-8ABA79F583BD}"/>
               </a:ext>
             </a:extLst>
           </p:cNvPr>
@@ -3354,7 +3354,7 @@
           <p:cNvPr id="4" name="Footer Placeholder 3">
             <a:extLst xmlns:a="http://schemas.openxmlformats.org/drawingml/2006/main">
               <a:ext uri="{FF2B5EF4-FFF2-40B4-BE49-F238E27FC236}">
-                <a16:creationId xmlns:a16="http://schemas.microsoft.com/office/drawing/2014/main" id="{AAAC6BE2-7537-4BEF-9A36-32A765EF774F}"/>
+                <a16:creationId xmlns:a16="http://schemas.microsoft.com/office/drawing/2014/main" id="{53D49956-5919-46CF-ACB0-7BFCA756C198}"/>
               </a:ext>
             </a:extLst>
           </p:cNvPr>
@@ -3379,7 +3379,7 @@
           <p:cNvPr id="5" name="Slide Number Placeholder 4">
             <a:extLst xmlns:a="http://schemas.openxmlformats.org/drawingml/2006/main">
               <a:ext uri="{FF2B5EF4-FFF2-40B4-BE49-F238E27FC236}">
-                <a16:creationId xmlns:a16="http://schemas.microsoft.com/office/drawing/2014/main" id="{EE2C93B1-AEE4-4145-904D-EACCC6D06DB8}"/>
+                <a16:creationId xmlns:a16="http://schemas.microsoft.com/office/drawing/2014/main" id="{EF63F121-07BD-48F2-A5B5-A00239AC1E77}"/>
               </a:ext>
             </a:extLst>
           </p:cNvPr>
@@ -3424,7 +3424,7 @@
           <p:cNvPr id="2" name="Date Placeholder 1">
             <a:extLst xmlns:a="http://schemas.openxmlformats.org/drawingml/2006/main">
               <a:ext uri="{FF2B5EF4-FFF2-40B4-BE49-F238E27FC236}">
-                <a16:creationId xmlns:a16="http://schemas.microsoft.com/office/drawing/2014/main" id="{599C931A-6484-4774-8032-34FC2C945AAE}"/>
+                <a16:creationId xmlns:a16="http://schemas.microsoft.com/office/drawing/2014/main" id="{0185D465-7B9B-45C3-B6D5-30883976CA90}"/>
               </a:ext>
             </a:extLst>
           </p:cNvPr>
@@ -3452,7 +3452,7 @@
           <p:cNvPr id="3" name="Footer Placeholder 2">
             <a:extLst xmlns:a="http://schemas.openxmlformats.org/drawingml/2006/main">
               <a:ext uri="{FF2B5EF4-FFF2-40B4-BE49-F238E27FC236}">
-                <a16:creationId xmlns:a16="http://schemas.microsoft.com/office/drawing/2014/main" id="{9AA050F6-BF6E-43F9-A135-EA80D9F41CB4}"/>
+                <a16:creationId xmlns:a16="http://schemas.microsoft.com/office/drawing/2014/main" id="{78E270E0-728D-4FD9-A4EA-0FCA135D3C06}"/>
               </a:ext>
             </a:extLst>
           </p:cNvPr>
@@ -3477,7 +3477,7 @@
           <p:cNvPr id="4" name="Slide Number Placeholder 3">
             <a:extLst xmlns:a="http://schemas.openxmlformats.org/drawingml/2006/main">
               <a:ext uri="{FF2B5EF4-FFF2-40B4-BE49-F238E27FC236}">
-                <a16:creationId xmlns:a16="http://schemas.microsoft.com/office/drawing/2014/main" id="{BAE96540-920C-4C20-AA57-EC6CB3D40566}"/>
+                <a16:creationId xmlns:a16="http://schemas.microsoft.com/office/drawing/2014/main" id="{A9A01E7B-DEF1-4BE3-AC14-97C9B4BAB350}"/>
               </a:ext>
             </a:extLst>
           </p:cNvPr>
@@ -3522,7 +3522,7 @@
           <p:cNvPr id="2" name="Title 1">
             <a:extLst xmlns:a="http://schemas.openxmlformats.org/drawingml/2006/main">
               <a:ext uri="{FF2B5EF4-FFF2-40B4-BE49-F238E27FC236}">
-                <a16:creationId xmlns:a16="http://schemas.microsoft.com/office/drawing/2014/main" id="{FB8B2180-6D24-4E7F-B4A7-24DB486386F5}"/>
+                <a16:creationId xmlns:a16="http://schemas.microsoft.com/office/drawing/2014/main" id="{29D54285-6C2F-4829-84AC-A40949FE83C2}"/>
               </a:ext>
             </a:extLst>
           </p:cNvPr>
@@ -3559,7 +3559,7 @@
           <p:cNvPr id="3" name="Content Placeholder 2">
             <a:extLst xmlns:a="http://schemas.openxmlformats.org/drawingml/2006/main">
               <a:ext uri="{FF2B5EF4-FFF2-40B4-BE49-F238E27FC236}">
-                <a16:creationId xmlns:a16="http://schemas.microsoft.com/office/drawing/2014/main" id="{C542C4AA-BE3C-4E36-9163-13C601F813A6}"/>
+                <a16:creationId xmlns:a16="http://schemas.microsoft.com/office/drawing/2014/main" id="{F9D984AF-5A7D-400A-AD86-0D868D31AB4D}"/>
               </a:ext>
             </a:extLst>
           </p:cNvPr>
@@ -3663,7 +3663,7 @@
           <p:cNvPr id="4" name="Text Placeholder 3">
             <a:extLst xmlns:a="http://schemas.openxmlformats.org/drawingml/2006/main">
               <a:ext uri="{FF2B5EF4-FFF2-40B4-BE49-F238E27FC236}">
-                <a16:creationId xmlns:a16="http://schemas.microsoft.com/office/drawing/2014/main" id="{112B7EB6-DB8B-4B3D-BE6E-E686BE5D6F7C}"/>
+                <a16:creationId xmlns:a16="http://schemas.microsoft.com/office/drawing/2014/main" id="{E643F314-D9C4-421C-99A4-01FA42F9F806}"/>
               </a:ext>
             </a:extLst>
           </p:cNvPr>
@@ -3735,7 +3735,7 @@
           <p:cNvPr id="5" name="Date Placeholder 4">
             <a:extLst xmlns:a="http://schemas.openxmlformats.org/drawingml/2006/main">
               <a:ext uri="{FF2B5EF4-FFF2-40B4-BE49-F238E27FC236}">
-                <a16:creationId xmlns:a16="http://schemas.microsoft.com/office/drawing/2014/main" id="{99147F19-B4CD-47C5-8347-0B178A32685D}"/>
+                <a16:creationId xmlns:a16="http://schemas.microsoft.com/office/drawing/2014/main" id="{F1E0A1D6-4DFF-4A38-B0D7-4956DB61EFBB}"/>
               </a:ext>
             </a:extLst>
           </p:cNvPr>
@@ -3763,7 +3763,7 @@
           <p:cNvPr id="6" name="Footer Placeholder 5">
             <a:extLst xmlns:a="http://schemas.openxmlformats.org/drawingml/2006/main">
               <a:ext uri="{FF2B5EF4-FFF2-40B4-BE49-F238E27FC236}">
-                <a16:creationId xmlns:a16="http://schemas.microsoft.com/office/drawing/2014/main" id="{5FF98153-8D4F-46E0-AA4A-88F39A1BFE6A}"/>
+                <a16:creationId xmlns:a16="http://schemas.microsoft.com/office/drawing/2014/main" id="{C20353DB-E981-4031-8018-BEC39167ABB1}"/>
               </a:ext>
             </a:extLst>
           </p:cNvPr>
@@ -3788,7 +3788,7 @@
           <p:cNvPr id="7" name="Slide Number Placeholder 6">
             <a:extLst xmlns:a="http://schemas.openxmlformats.org/drawingml/2006/main">
               <a:ext uri="{FF2B5EF4-FFF2-40B4-BE49-F238E27FC236}">
-                <a16:creationId xmlns:a16="http://schemas.microsoft.com/office/drawing/2014/main" id="{BB1474AF-C582-454E-848D-6785B3DDFB47}"/>
+                <a16:creationId xmlns:a16="http://schemas.microsoft.com/office/drawing/2014/main" id="{B729964C-CF2F-478B-82E8-53FE29B5D3A5}"/>
               </a:ext>
             </a:extLst>
           </p:cNvPr>
@@ -3833,7 +3833,7 @@
           <p:cNvPr id="2" name="Title 1">
             <a:extLst xmlns:a="http://schemas.openxmlformats.org/drawingml/2006/main">
               <a:ext uri="{FF2B5EF4-FFF2-40B4-BE49-F238E27FC236}">
-                <a16:creationId xmlns:a16="http://schemas.microsoft.com/office/drawing/2014/main" id="{D8B942FE-C729-4CA8-B23F-77C4905E2E91}"/>
+                <a16:creationId xmlns:a16="http://schemas.microsoft.com/office/drawing/2014/main" id="{C0F177DE-81BE-438A-B7EC-02B4420D6D34}"/>
               </a:ext>
             </a:extLst>
           </p:cNvPr>
@@ -3870,7 +3870,7 @@
           <p:cNvPr id="3" name="Picture Placeholder 2">
             <a:extLst xmlns:a="http://schemas.openxmlformats.org/drawingml/2006/main">
               <a:ext uri="{FF2B5EF4-FFF2-40B4-BE49-F238E27FC236}">
-                <a16:creationId xmlns:a16="http://schemas.microsoft.com/office/drawing/2014/main" id="{E70A1F56-27D1-41AE-9D25-0F2B866F71C3}"/>
+                <a16:creationId xmlns:a16="http://schemas.microsoft.com/office/drawing/2014/main" id="{A528D91F-2760-4CBD-BF53-BB596BCAD49D}"/>
               </a:ext>
             </a:extLst>
           </p:cNvPr>
@@ -3937,7 +3937,7 @@
           <p:cNvPr id="4" name="Text Placeholder 3">
             <a:extLst xmlns:a="http://schemas.openxmlformats.org/drawingml/2006/main">
               <a:ext uri="{FF2B5EF4-FFF2-40B4-BE49-F238E27FC236}">
-                <a16:creationId xmlns:a16="http://schemas.microsoft.com/office/drawing/2014/main" id="{B4C42BF4-F878-4E10-B27D-4FDB948C1E6E}"/>
+                <a16:creationId xmlns:a16="http://schemas.microsoft.com/office/drawing/2014/main" id="{B4F5AE71-BB7C-49B1-B7BD-5DAE463876F0}"/>
               </a:ext>
             </a:extLst>
           </p:cNvPr>
@@ -4009,7 +4009,7 @@
           <p:cNvPr id="5" name="Date Placeholder 4">
             <a:extLst xmlns:a="http://schemas.openxmlformats.org/drawingml/2006/main">
               <a:ext uri="{FF2B5EF4-FFF2-40B4-BE49-F238E27FC236}">
-                <a16:creationId xmlns:a16="http://schemas.microsoft.com/office/drawing/2014/main" id="{B680D908-5D5D-4674-B8D5-A6F778B1AE31}"/>
+                <a16:creationId xmlns:a16="http://schemas.microsoft.com/office/drawing/2014/main" id="{1E2F4CF1-70B0-495D-A575-6B666E6665E1}"/>
               </a:ext>
             </a:extLst>
           </p:cNvPr>
@@ -4037,7 +4037,7 @@
           <p:cNvPr id="6" name="Footer Placeholder 5">
             <a:extLst xmlns:a="http://schemas.openxmlformats.org/drawingml/2006/main">
               <a:ext uri="{FF2B5EF4-FFF2-40B4-BE49-F238E27FC236}">
-                <a16:creationId xmlns:a16="http://schemas.microsoft.com/office/drawing/2014/main" id="{61E97864-4BED-4918-B40E-2EBE090B5BE3}"/>
+                <a16:creationId xmlns:a16="http://schemas.microsoft.com/office/drawing/2014/main" id="{9725B80D-B577-4789-9C78-6D55054665E0}"/>
               </a:ext>
             </a:extLst>
           </p:cNvPr>
@@ -4062,7 +4062,7 @@
           <p:cNvPr id="7" name="Slide Number Placeholder 6">
             <a:extLst xmlns:a="http://schemas.openxmlformats.org/drawingml/2006/main">
               <a:ext uri="{FF2B5EF4-FFF2-40B4-BE49-F238E27FC236}">
-                <a16:creationId xmlns:a16="http://schemas.microsoft.com/office/drawing/2014/main" id="{B765519D-F147-4E7E-AD08-8A9BCC887CA7}"/>
+                <a16:creationId xmlns:a16="http://schemas.microsoft.com/office/drawing/2014/main" id="{4CBB8C83-C7BE-4A32-A708-E6556420C8AB}"/>
               </a:ext>
             </a:extLst>
           </p:cNvPr>
@@ -4112,7 +4112,7 @@
           <p:cNvPr id="2" name="Title Placeholder 1">
             <a:extLst xmlns:a="http://schemas.openxmlformats.org/drawingml/2006/main">
               <a:ext uri="{FF2B5EF4-FFF2-40B4-BE49-F238E27FC236}">
-                <a16:creationId xmlns:a16="http://schemas.microsoft.com/office/drawing/2014/main" id="{1506465D-87E8-415D-B371-7F266D180145}"/>
+                <a16:creationId xmlns:a16="http://schemas.microsoft.com/office/drawing/2014/main" id="{BA554307-1D22-4934-9F46-7F7ABEA9E67E}"/>
               </a:ext>
             </a:extLst>
           </p:cNvPr>
@@ -4149,7 +4149,7 @@
           <p:cNvPr id="3" name="Text Placeholder 2">
             <a:extLst xmlns:a="http://schemas.openxmlformats.org/drawingml/2006/main">
               <a:ext uri="{FF2B5EF4-FFF2-40B4-BE49-F238E27FC236}">
-                <a16:creationId xmlns:a16="http://schemas.microsoft.com/office/drawing/2014/main" id="{37E78190-38F1-4DCE-8D16-DA5FA15F2F39}"/>
+                <a16:creationId xmlns:a16="http://schemas.microsoft.com/office/drawing/2014/main" id="{75179155-D45A-483A-B677-45CAF6D412B9}"/>
               </a:ext>
             </a:extLst>
           </p:cNvPr>
@@ -4221,7 +4221,7 @@
           <p:cNvPr id="4" name="Date Placeholder 3">
             <a:extLst xmlns:a="http://schemas.openxmlformats.org/drawingml/2006/main">
               <a:ext uri="{FF2B5EF4-FFF2-40B4-BE49-F238E27FC236}">
-                <a16:creationId xmlns:a16="http://schemas.microsoft.com/office/drawing/2014/main" id="{5A99888F-AC56-4EF9-A291-353A1E9EF76D}"/>
+                <a16:creationId xmlns:a16="http://schemas.microsoft.com/office/drawing/2014/main" id="{597522D5-FBB7-45AA-AAE2-A65F0205183D}"/>
               </a:ext>
             </a:extLst>
           </p:cNvPr>
@@ -4268,7 +4268,7 @@
           <p:cNvPr id="5" name="Footer Placeholder 4">
             <a:extLst xmlns:a="http://schemas.openxmlformats.org/drawingml/2006/main">
               <a:ext uri="{FF2B5EF4-FFF2-40B4-BE49-F238E27FC236}">
-                <a16:creationId xmlns:a16="http://schemas.microsoft.com/office/drawing/2014/main" id="{0510A8E7-58F1-49F5-99A7-AC173F71BF60}"/>
+                <a16:creationId xmlns:a16="http://schemas.microsoft.com/office/drawing/2014/main" id="{C2A0D7F8-EB8D-46F5-91F6-459D80694674}"/>
               </a:ext>
             </a:extLst>
           </p:cNvPr>
@@ -4312,7 +4312,7 @@
           <p:cNvPr id="6" name="Slide Number Placeholder 5">
             <a:extLst xmlns:a="http://schemas.openxmlformats.org/drawingml/2006/main">
               <a:ext uri="{FF2B5EF4-FFF2-40B4-BE49-F238E27FC236}">
-                <a16:creationId xmlns:a16="http://schemas.microsoft.com/office/drawing/2014/main" id="{C8F69C1C-15AD-478E-8CBF-D6AAAF27E3E5}"/>
+                <a16:creationId xmlns:a16="http://schemas.microsoft.com/office/drawing/2014/main" id="{F063661A-76B7-4EEF-B4CD-AAB6E5870672}"/>
               </a:ext>
             </a:extLst>
           </p:cNvPr>
@@ -4358,17 +4358,17 @@
   </p:cSld>
   <p:clrMap bg1="lt1" tx1="dk1" bg2="lt2" tx2="dk2" accent1="accent1" accent2="accent2" accent3="accent3" accent4="accent4" accent5="accent5" accent6="accent6" hlink="hlink" folHlink="folHlink"/>
   <p:sldLayoutIdLst>
-    <p:sldLayoutId xmlns:r="http://schemas.openxmlformats.org/officeDocument/2006/relationships" id="2147483649" r:id="R56be095cfddb4e77"/>
-    <p:sldLayoutId xmlns:r="http://schemas.openxmlformats.org/officeDocument/2006/relationships" id="2147483650" r:id="R6a1add4c9c594403"/>
-    <p:sldLayoutId xmlns:r="http://schemas.openxmlformats.org/officeDocument/2006/relationships" id="2147483651" r:id="R53f36a29ed6b449c"/>
-    <p:sldLayoutId xmlns:r="http://schemas.openxmlformats.org/officeDocument/2006/relationships" id="2147483652" r:id="Rf0856e3602934eb5"/>
-    <p:sldLayoutId xmlns:r="http://schemas.openxmlformats.org/officeDocument/2006/relationships" id="2147483653" r:id="Rbc5cbd21a1d94ffe"/>
-    <p:sldLayoutId xmlns:r="http://schemas.openxmlformats.org/officeDocument/2006/relationships" id="2147483654" r:id="Rc5e449e56d674eb4"/>
-    <p:sldLayoutId xmlns:r="http://schemas.openxmlformats.org/officeDocument/2006/relationships" id="2147483655" r:id="Rbfbc915ae70e4ef9"/>
-    <p:sldLayoutId xmlns:r="http://schemas.openxmlformats.org/officeDocument/2006/relationships" id="2147483656" r:id="R7a86221af58b4a2a"/>
-    <p:sldLayoutId xmlns:r="http://schemas.openxmlformats.org/officeDocument/2006/relationships" id="2147483657" r:id="R3767527b36e046cf"/>
-    <p:sldLayoutId xmlns:r="http://schemas.openxmlformats.org/officeDocument/2006/relationships" id="2147483658" r:id="R4b7e653de69d4863"/>
-    <p:sldLayoutId xmlns:r="http://schemas.openxmlformats.org/officeDocument/2006/relationships" id="2147483659" r:id="R63506dd3112a4133"/>
+    <p:sldLayoutId xmlns:r="http://schemas.openxmlformats.org/officeDocument/2006/relationships" id="2147483649" r:id="Rd5f6b2db4db9489a"/>
+    <p:sldLayoutId xmlns:r="http://schemas.openxmlformats.org/officeDocument/2006/relationships" id="2147483650" r:id="R5a4f4aadc1824659"/>
+    <p:sldLayoutId xmlns:r="http://schemas.openxmlformats.org/officeDocument/2006/relationships" id="2147483651" r:id="Re6e23469e5994dd2"/>
+    <p:sldLayoutId xmlns:r="http://schemas.openxmlformats.org/officeDocument/2006/relationships" id="2147483652" r:id="R9f71e9dfae0d43bd"/>
+    <p:sldLayoutId xmlns:r="http://schemas.openxmlformats.org/officeDocument/2006/relationships" id="2147483653" r:id="R623fc3e9fa904b21"/>
+    <p:sldLayoutId xmlns:r="http://schemas.openxmlformats.org/officeDocument/2006/relationships" id="2147483654" r:id="R83deef58bbfe4821"/>
+    <p:sldLayoutId xmlns:r="http://schemas.openxmlformats.org/officeDocument/2006/relationships" id="2147483655" r:id="R2e18c815384f4b55"/>
+    <p:sldLayoutId xmlns:r="http://schemas.openxmlformats.org/officeDocument/2006/relationships" id="2147483656" r:id="Rcd2b8e1a6a6e4454"/>
+    <p:sldLayoutId xmlns:r="http://schemas.openxmlformats.org/officeDocument/2006/relationships" id="2147483657" r:id="Re169fcb832894685"/>
+    <p:sldLayoutId xmlns:r="http://schemas.openxmlformats.org/officeDocument/2006/relationships" id="2147483658" r:id="R5b3fffef2d6848d7"/>
+    <p:sldLayoutId xmlns:r="http://schemas.openxmlformats.org/officeDocument/2006/relationships" id="2147483659" r:id="Rb4e6974b45794057"/>
   </p:sldLayoutIdLst>
   <p:txStyles>
     <p:titleStyle>
@@ -4923,7 +4923,7 @@
           <p:cNvPr id="2" name="Freeform 2">
             <a:extLst xmlns:a="http://schemas.openxmlformats.org/drawingml/2006/main">
               <a:ext uri="{FF2B5EF4-FFF2-40B4-BE49-F238E27FC236}">
-                <a16:creationId xmlns:a16="http://schemas.microsoft.com/office/drawing/2014/main" id="{2098B14C-0C0F-4026-85B4-2FBFC6C8D2D1}"/>
+                <a16:creationId xmlns:a16="http://schemas.microsoft.com/office/drawing/2014/main" id="{1E70E403-1009-4A24-96DD-E6C99A7F8BDC}"/>
               </a:ext>
             </a:extLst>
           </p:cNvPr>
@@ -4961,7 +4961,7 @@
             </a:pathLst>
           </a:custGeom>
           <a:blipFill xmlns:a="http://schemas.openxmlformats.org/drawingml/2006/main">
-            <a:blip xmlns:r="http://schemas.openxmlformats.org/officeDocument/2006/relationships" r:embed="R9970fb117ad04a62"/>
+            <a:blip xmlns:r="http://schemas.openxmlformats.org/officeDocument/2006/relationships" r:embed="R584a94db65924e45"/>
             <a:stretch>
               <a:fillRect l="-15070" t="-4622" r="-22184" b="-2965"/>
             </a:stretch>
@@ -4980,7 +4980,7 @@
           <p:cNvPr id="3" name="Freeform 3">
             <a:extLst xmlns:a="http://schemas.openxmlformats.org/drawingml/2006/main">
               <a:ext uri="{FF2B5EF4-FFF2-40B4-BE49-F238E27FC236}">
-                <a16:creationId xmlns:a16="http://schemas.microsoft.com/office/drawing/2014/main" id="{8C4C3DD9-A012-4679-9678-5DCDAA543699}"/>
+                <a16:creationId xmlns:a16="http://schemas.microsoft.com/office/drawing/2014/main" id="{301F37C6-A585-48F3-A0A8-370D6AF87D09}"/>
               </a:ext>
             </a:extLst>
           </p:cNvPr>
@@ -5018,7 +5018,7 @@
             </a:pathLst>
           </a:custGeom>
           <a:blipFill xmlns:a="http://schemas.openxmlformats.org/drawingml/2006/main">
-            <a:blip xmlns:r="http://schemas.openxmlformats.org/officeDocument/2006/relationships" r:embed="R19a196de06be4bf6"/>
+            <a:blip xmlns:r="http://schemas.openxmlformats.org/officeDocument/2006/relationships" r:embed="R154fe742f7d248fd"/>
             <a:stretch>
               <a:fillRect l="0" t="0" r="0" b="0"/>
             </a:stretch>
@@ -5037,7 +5037,7 @@
           <p:cNvPr id="4" name="TextBox 4">
             <a:extLst xmlns:a="http://schemas.openxmlformats.org/drawingml/2006/main">
               <a:ext uri="{FF2B5EF4-FFF2-40B4-BE49-F238E27FC236}">
-                <a16:creationId xmlns:a16="http://schemas.microsoft.com/office/drawing/2014/main" id="{EF484E58-69C5-4D2D-B293-3203D4098A20}"/>
+                <a16:creationId xmlns:a16="http://schemas.microsoft.com/office/drawing/2014/main" id="{019FE0A6-A46B-4C70-A82A-FA1EBC8A9681}"/>
               </a:ext>
             </a:extLst>
           </p:cNvPr>
@@ -5130,7 +5130,7 @@
           <p:cNvPr id="5" name="TextBox 5">
             <a:extLst xmlns:a="http://schemas.openxmlformats.org/drawingml/2006/main">
               <a:ext uri="{FF2B5EF4-FFF2-40B4-BE49-F238E27FC236}">
-                <a16:creationId xmlns:a16="http://schemas.microsoft.com/office/drawing/2014/main" id="{0075BF87-B1F5-4C65-A4D3-9DAEDAF2CF2C}"/>
+                <a16:creationId xmlns:a16="http://schemas.microsoft.com/office/drawing/2014/main" id="{8C3B7752-EDA3-4EE1-9331-BD2A23089598}"/>
               </a:ext>
             </a:extLst>
           </p:cNvPr>
@@ -5198,7 +5198,7 @@
           <p:cNvPr id="6" name="TextBox 6">
             <a:extLst xmlns:a="http://schemas.openxmlformats.org/drawingml/2006/main">
               <a:ext uri="{FF2B5EF4-FFF2-40B4-BE49-F238E27FC236}">
-                <a16:creationId xmlns:a16="http://schemas.microsoft.com/office/drawing/2014/main" id="{C33AA2F4-672D-4F4A-A301-7E2DB24E8C36}"/>
+                <a16:creationId xmlns:a16="http://schemas.microsoft.com/office/drawing/2014/main" id="{45586C9A-D461-43BB-86CA-D00623A86F48}"/>
               </a:ext>
             </a:extLst>
           </p:cNvPr>
@@ -5240,7 +5240,7 @@
                 <a:ea typeface="Times New Roman"/>
                 <a:cs typeface="Times New Roman"/>
               </a:rPr>
-              <a:t>Team Number: 4</a:t>
+              <a:t>Team Number: 3</a:t>
             </a:r>
           </a:p>
         </p:txBody>
@@ -5250,7 +5250,7 @@
           <p:cNvPr id="8" name="TextBox 8">
             <a:extLst xmlns:a="http://schemas.openxmlformats.org/drawingml/2006/main">
               <a:ext uri="{FF2B5EF4-FFF2-40B4-BE49-F238E27FC236}">
-                <a16:creationId xmlns:a16="http://schemas.microsoft.com/office/drawing/2014/main" id="{5064203D-65AF-4EE3-BFB2-FAE28106FD5E}"/>
+                <a16:creationId xmlns:a16="http://schemas.microsoft.com/office/drawing/2014/main" id="{174C103D-6E70-4B62-8BC6-BAC21C4B9169}"/>
               </a:ext>
             </a:extLst>
           </p:cNvPr>
@@ -5302,7 +5302,7 @@
           <p:cNvPr id="9" name="">
             <a:extLst xmlns:a="http://schemas.openxmlformats.org/drawingml/2006/main">
               <a:ext uri="{FF2B5EF4-FFF2-40B4-BE49-F238E27FC236}">
-                <a16:creationId xmlns:a16="http://schemas.microsoft.com/office/drawing/2014/main" id="{1CBCA4C1-8272-4E07-9B1F-936156A1A125}"/>
+                <a16:creationId xmlns:a16="http://schemas.microsoft.com/office/drawing/2014/main" id="{52E8D6C9-A8A4-47A8-BC58-FBB9760FA3F2}"/>
               </a:ext>
             </a:extLst>
           </p:cNvPr>
@@ -5359,7 +5359,7 @@
           <p:cNvPr id="10" name="">
             <a:extLst xmlns:a="http://schemas.openxmlformats.org/drawingml/2006/main">
               <a:ext uri="{FF2B5EF4-FFF2-40B4-BE49-F238E27FC236}">
-                <a16:creationId xmlns:a16="http://schemas.microsoft.com/office/drawing/2014/main" id="{0E2A8F17-07D5-4C8E-8857-C51343B879EF}"/>
+                <a16:creationId xmlns:a16="http://schemas.microsoft.com/office/drawing/2014/main" id="{5520A9A3-8432-48AF-9761-2D4E4A8ECFE3}"/>
               </a:ext>
             </a:extLst>
           </p:cNvPr>
@@ -5414,7 +5414,7 @@
     </p:spTree>
     <p:extLst>
       <p:ext uri="{BB962C8B-B14F-4D97-AF65-F5344CB8AC3E}">
-        <p14:creationId xmlns:p14="http://schemas.microsoft.com/office/powerpoint/2010/main" val="1951280120"/>
+        <p14:creationId xmlns:p14="http://schemas.microsoft.com/office/powerpoint/2010/main" val="116128373"/>
       </p:ext>
     </p:extLst>
   </p:cSld>
@@ -5445,7 +5445,7 @@
           <p:cNvPr id="3" name="Freeform 3">
             <a:extLst xmlns:a="http://schemas.openxmlformats.org/drawingml/2006/main">
               <a:ext uri="{FF2B5EF4-FFF2-40B4-BE49-F238E27FC236}">
-                <a16:creationId xmlns:a16="http://schemas.microsoft.com/office/drawing/2014/main" id="{63DE4F38-419F-4F30-94A0-786B7D340B61}"/>
+                <a16:creationId xmlns:a16="http://schemas.microsoft.com/office/drawing/2014/main" id="{9F916760-1567-452E-9309-B8D599890680}"/>
               </a:ext>
             </a:extLst>
           </p:cNvPr>
@@ -5508,7 +5508,7 @@
           <p:cNvPr id="4" name="TextBox 4">
             <a:extLst xmlns:a="http://schemas.openxmlformats.org/drawingml/2006/main">
               <a:ext uri="{FF2B5EF4-FFF2-40B4-BE49-F238E27FC236}">
-                <a16:creationId xmlns:a16="http://schemas.microsoft.com/office/drawing/2014/main" id="{966B660F-8950-49B7-BB98-BF8D375F0D22}"/>
+                <a16:creationId xmlns:a16="http://schemas.microsoft.com/office/drawing/2014/main" id="{B7A5140E-C6BA-4713-A60E-07B383D65FF8}"/>
               </a:ext>
             </a:extLst>
           </p:cNvPr>
@@ -5545,7 +5545,7 @@
           <p:cNvPr id="5" name="Freeform 5">
             <a:extLst xmlns:a="http://schemas.openxmlformats.org/drawingml/2006/main">
               <a:ext uri="{FF2B5EF4-FFF2-40B4-BE49-F238E27FC236}">
-                <a16:creationId xmlns:a16="http://schemas.microsoft.com/office/drawing/2014/main" id="{C8C2F941-E6B3-4B85-BB60-45817DD98B6F}"/>
+                <a16:creationId xmlns:a16="http://schemas.microsoft.com/office/drawing/2014/main" id="{0C8E067E-26C2-4429-8A3B-38704BBC8BC6}"/>
               </a:ext>
             </a:extLst>
           </p:cNvPr>
@@ -5583,10 +5583,10 @@
             </a:pathLst>
           </a:custGeom>
           <a:blipFill xmlns:a="http://schemas.openxmlformats.org/drawingml/2006/main">
-            <a:blip xmlns:r="http://schemas.openxmlformats.org/officeDocument/2006/relationships" r:embed="Rabb47a11e8694fcf">
+            <a:blip xmlns:r="http://schemas.openxmlformats.org/officeDocument/2006/relationships" r:embed="R1cc612407fd440b3">
               <a:extLst>
                 <a:ext uri="{96DAC541-7B7A-43D3-8B79-37D633B846F1}">
-                  <asvg:svgBlip xmlns:asvg="http://schemas.microsoft.com/office/drawing/2016/SVG/main" r:embed="R0729cff1bed043f2"/>
+                  <asvg:svgBlip xmlns:asvg="http://schemas.microsoft.com/office/drawing/2016/SVG/main" r:embed="Rfde8a197865a4461"/>
                 </a:ext>
               </a:extLst>
             </a:blip>
@@ -6100,7 +6100,7 @@
                         <a:buNone/>
                       </a:pPr>
                       <a:r>
-                        <a:t>Team No. 4 (shared)</a:t>
+                        <a:t>Team No. 3 (shared)</a:t>
                       </a:r>
                       <a:endParaRPr sz="1100"/>
                     </a:p>
@@ -6186,7 +6186,7 @@
           <p:cNvPr id="7" name="TextBox 7">
             <a:extLst xmlns:a="http://schemas.openxmlformats.org/drawingml/2006/main">
               <a:ext uri="{FF2B5EF4-FFF2-40B4-BE49-F238E27FC236}">
-                <a16:creationId xmlns:a16="http://schemas.microsoft.com/office/drawing/2014/main" id="{CD08C099-E44F-4FE5-A07B-47A5C2440F1C}"/>
+                <a16:creationId xmlns:a16="http://schemas.microsoft.com/office/drawing/2014/main" id="{3CD1D617-80FB-45A3-9646-F3E0682BB0FD}"/>
               </a:ext>
             </a:extLst>
           </p:cNvPr>
@@ -6236,7 +6236,7 @@
     </p:spTree>
     <p:extLst>
       <p:ext uri="{BB962C8B-B14F-4D97-AF65-F5344CB8AC3E}">
-        <p14:creationId xmlns:p14="http://schemas.microsoft.com/office/powerpoint/2010/main" val="147882817"/>
+        <p14:creationId xmlns:p14="http://schemas.microsoft.com/office/powerpoint/2010/main" val="442629300"/>
       </p:ext>
     </p:extLst>
   </p:cSld>
@@ -6267,7 +6267,7 @@
           <p:cNvPr id="3" name="Freeform 3">
             <a:extLst xmlns:a="http://schemas.openxmlformats.org/drawingml/2006/main">
               <a:ext uri="{FF2B5EF4-FFF2-40B4-BE49-F238E27FC236}">
-                <a16:creationId xmlns:a16="http://schemas.microsoft.com/office/drawing/2014/main" id="{9E954ED4-833B-40F3-A319-69DB719E2DEE}"/>
+                <a16:creationId xmlns:a16="http://schemas.microsoft.com/office/drawing/2014/main" id="{16CCF266-2BA6-44BF-A75F-2D42B39614EC}"/>
               </a:ext>
             </a:extLst>
           </p:cNvPr>
@@ -6330,7 +6330,7 @@
           <p:cNvPr id="4" name="TextBox 4">
             <a:extLst xmlns:a="http://schemas.openxmlformats.org/drawingml/2006/main">
               <a:ext uri="{FF2B5EF4-FFF2-40B4-BE49-F238E27FC236}">
-                <a16:creationId xmlns:a16="http://schemas.microsoft.com/office/drawing/2014/main" id="{D6B3DB31-7B98-49EA-8B51-DA937B61744A}"/>
+                <a16:creationId xmlns:a16="http://schemas.microsoft.com/office/drawing/2014/main" id="{53952DBF-2192-4AAD-AB63-E01861A6D1EF}"/>
               </a:ext>
             </a:extLst>
           </p:cNvPr>
@@ -6367,7 +6367,7 @@
           <p:cNvPr id="5" name="Freeform 5">
             <a:extLst xmlns:a="http://schemas.openxmlformats.org/drawingml/2006/main">
               <a:ext uri="{FF2B5EF4-FFF2-40B4-BE49-F238E27FC236}">
-                <a16:creationId xmlns:a16="http://schemas.microsoft.com/office/drawing/2014/main" id="{08070E9C-5E49-42B8-AC7A-C3CCB1542597}"/>
+                <a16:creationId xmlns:a16="http://schemas.microsoft.com/office/drawing/2014/main" id="{CA4635CC-F6BE-4F33-83FF-33A7563717FB}"/>
               </a:ext>
             </a:extLst>
           </p:cNvPr>
@@ -6405,10 +6405,10 @@
             </a:pathLst>
           </a:custGeom>
           <a:blipFill xmlns:a="http://schemas.openxmlformats.org/drawingml/2006/main">
-            <a:blip xmlns:r="http://schemas.openxmlformats.org/officeDocument/2006/relationships" r:embed="R726580433f1b4994">
+            <a:blip xmlns:r="http://schemas.openxmlformats.org/officeDocument/2006/relationships" r:embed="R89b4f9d4df5448a2">
               <a:extLst>
                 <a:ext uri="{96DAC541-7B7A-43D3-8B79-37D633B846F1}">
-                  <asvg:svgBlip xmlns:asvg="http://schemas.microsoft.com/office/drawing/2016/SVG/main" r:embed="R9985f40333bf49c9"/>
+                  <asvg:svgBlip xmlns:asvg="http://schemas.microsoft.com/office/drawing/2016/SVG/main" r:embed="R29195a56dcda40dc"/>
                 </a:ext>
               </a:extLst>
             </a:blip>
@@ -6430,7 +6430,7 @@
           <p:cNvPr id="6" name="TextBox 6">
             <a:extLst xmlns:a="http://schemas.openxmlformats.org/drawingml/2006/main">
               <a:ext uri="{FF2B5EF4-FFF2-40B4-BE49-F238E27FC236}">
-                <a16:creationId xmlns:a16="http://schemas.microsoft.com/office/drawing/2014/main" id="{2057B701-0606-41ED-8208-BA7F7BF5B858}"/>
+                <a16:creationId xmlns:a16="http://schemas.microsoft.com/office/drawing/2014/main" id="{709BCF04-BB9F-40AC-9E77-DBBD33794E4B}"/>
               </a:ext>
             </a:extLst>
           </p:cNvPr>
@@ -6479,7 +6479,7 @@
           <p:cNvPr id="7" name="TextBox 7">
             <a:extLst xmlns:a="http://schemas.openxmlformats.org/drawingml/2006/main">
               <a:ext uri="{FF2B5EF4-FFF2-40B4-BE49-F238E27FC236}">
-                <a16:creationId xmlns:a16="http://schemas.microsoft.com/office/drawing/2014/main" id="{BD7F09BB-78DA-49EC-B1A7-836C0B112FDB}"/>
+                <a16:creationId xmlns:a16="http://schemas.microsoft.com/office/drawing/2014/main" id="{0B474481-0702-4AAE-9CCF-7FC38D9BFFDF}"/>
               </a:ext>
             </a:extLst>
           </p:cNvPr>
@@ -6531,7 +6531,7 @@
           <p:cNvPr id="8" name="">
             <a:extLst xmlns:a="http://schemas.openxmlformats.org/drawingml/2006/main">
               <a:ext uri="{FF2B5EF4-FFF2-40B4-BE49-F238E27FC236}">
-                <a16:creationId xmlns:a16="http://schemas.microsoft.com/office/drawing/2014/main" id="{6BAA4290-F1C2-4D5C-B2E0-2EF25EE1EF09}"/>
+                <a16:creationId xmlns:a16="http://schemas.microsoft.com/office/drawing/2014/main" id="{D881CCB2-6153-40C4-A2FB-54E550868FF4}"/>
               </a:ext>
             </a:extLst>
           </p:cNvPr>
@@ -6561,7 +6561,7 @@
           <p:cNvPr id="9" name="">
             <a:extLst xmlns:a="http://schemas.openxmlformats.org/drawingml/2006/main">
               <a:ext uri="{FF2B5EF4-FFF2-40B4-BE49-F238E27FC236}">
-                <a16:creationId xmlns:a16="http://schemas.microsoft.com/office/drawing/2014/main" id="{865304E9-426D-4ADA-ABDA-53C2879401B8}"/>
+                <a16:creationId xmlns:a16="http://schemas.microsoft.com/office/drawing/2014/main" id="{C20A095F-B011-4BE5-881A-6232E589A0A5}"/>
               </a:ext>
             </a:extLst>
           </p:cNvPr>
@@ -6618,7 +6618,7 @@
           <p:cNvPr id="10" name="">
             <a:extLst xmlns:a="http://schemas.openxmlformats.org/drawingml/2006/main">
               <a:ext uri="{FF2B5EF4-FFF2-40B4-BE49-F238E27FC236}">
-                <a16:creationId xmlns:a16="http://schemas.microsoft.com/office/drawing/2014/main" id="{7FDFC1B2-6F83-4A9E-84EB-7EDEF90E3445}"/>
+                <a16:creationId xmlns:a16="http://schemas.microsoft.com/office/drawing/2014/main" id="{38D4557A-0D99-4B4E-9212-206263DB3CE0}"/>
               </a:ext>
             </a:extLst>
           </p:cNvPr>
@@ -6648,7 +6648,7 @@
           <p:cNvPr id="11" name="">
             <a:extLst xmlns:a="http://schemas.openxmlformats.org/drawingml/2006/main">
               <a:ext uri="{FF2B5EF4-FFF2-40B4-BE49-F238E27FC236}">
-                <a16:creationId xmlns:a16="http://schemas.microsoft.com/office/drawing/2014/main" id="{67966E6F-DE23-45EA-8C20-CCB94E7F2B44}"/>
+                <a16:creationId xmlns:a16="http://schemas.microsoft.com/office/drawing/2014/main" id="{71DFA230-493B-491F-AFF8-2A558A61C955}"/>
               </a:ext>
             </a:extLst>
           </p:cNvPr>
@@ -6705,7 +6705,7 @@
           <p:cNvPr id="12" name="">
             <a:extLst xmlns:a="http://schemas.openxmlformats.org/drawingml/2006/main">
               <a:ext uri="{FF2B5EF4-FFF2-40B4-BE49-F238E27FC236}">
-                <a16:creationId xmlns:a16="http://schemas.microsoft.com/office/drawing/2014/main" id="{62DFB09A-51BB-4DA1-BFAE-AC7A2956A286}"/>
+                <a16:creationId xmlns:a16="http://schemas.microsoft.com/office/drawing/2014/main" id="{5A29EE66-634F-453D-AD10-3C170D53B1D7}"/>
               </a:ext>
             </a:extLst>
           </p:cNvPr>
@@ -6735,7 +6735,7 @@
           <p:cNvPr id="13" name="">
             <a:extLst xmlns:a="http://schemas.openxmlformats.org/drawingml/2006/main">
               <a:ext uri="{FF2B5EF4-FFF2-40B4-BE49-F238E27FC236}">
-                <a16:creationId xmlns:a16="http://schemas.microsoft.com/office/drawing/2014/main" id="{E0D70027-37D9-4C00-9538-5728D9A87DB5}"/>
+                <a16:creationId xmlns:a16="http://schemas.microsoft.com/office/drawing/2014/main" id="{EC606BCE-8B51-40D1-9DFA-08D339D3420D}"/>
               </a:ext>
             </a:extLst>
           </p:cNvPr>
@@ -6792,7 +6792,7 @@
           <p:cNvPr id="14" name="">
             <a:extLst xmlns:a="http://schemas.openxmlformats.org/drawingml/2006/main">
               <a:ext uri="{FF2B5EF4-FFF2-40B4-BE49-F238E27FC236}">
-                <a16:creationId xmlns:a16="http://schemas.microsoft.com/office/drawing/2014/main" id="{3952B0B2-38E8-4627-9D1B-79FF4D6E0D66}"/>
+                <a16:creationId xmlns:a16="http://schemas.microsoft.com/office/drawing/2014/main" id="{3823750F-0987-4431-95F9-0FAE02F9C501}"/>
               </a:ext>
             </a:extLst>
           </p:cNvPr>
@@ -6822,7 +6822,7 @@
           <p:cNvPr id="15" name="">
             <a:extLst xmlns:a="http://schemas.openxmlformats.org/drawingml/2006/main">
               <a:ext uri="{FF2B5EF4-FFF2-40B4-BE49-F238E27FC236}">
-                <a16:creationId xmlns:a16="http://schemas.microsoft.com/office/drawing/2014/main" id="{C3B33DB1-1090-44BE-B890-8C4AB58A4814}"/>
+                <a16:creationId xmlns:a16="http://schemas.microsoft.com/office/drawing/2014/main" id="{B5566180-AD50-4694-AF2E-4AE9B33F339E}"/>
               </a:ext>
             </a:extLst>
           </p:cNvPr>
@@ -6877,7 +6877,7 @@
     </p:spTree>
     <p:extLst>
       <p:ext uri="{BB962C8B-B14F-4D97-AF65-F5344CB8AC3E}">
-        <p14:creationId xmlns:p14="http://schemas.microsoft.com/office/powerpoint/2010/main" val="1877979650"/>
+        <p14:creationId xmlns:p14="http://schemas.microsoft.com/office/powerpoint/2010/main" val="2018924424"/>
       </p:ext>
     </p:extLst>
   </p:cSld>
@@ -6908,7 +6908,7 @@
           <p:cNvPr id="3" name="Freeform 3">
             <a:extLst xmlns:a="http://schemas.openxmlformats.org/drawingml/2006/main">
               <a:ext uri="{FF2B5EF4-FFF2-40B4-BE49-F238E27FC236}">
-                <a16:creationId xmlns:a16="http://schemas.microsoft.com/office/drawing/2014/main" id="{ACD8884C-1455-4FDF-85CA-FF902EB84456}"/>
+                <a16:creationId xmlns:a16="http://schemas.microsoft.com/office/drawing/2014/main" id="{3DDD97ED-463C-4BAA-88E4-A6462E421790}"/>
               </a:ext>
             </a:extLst>
           </p:cNvPr>
@@ -6971,7 +6971,7 @@
           <p:cNvPr id="4" name="TextBox 4">
             <a:extLst xmlns:a="http://schemas.openxmlformats.org/drawingml/2006/main">
               <a:ext uri="{FF2B5EF4-FFF2-40B4-BE49-F238E27FC236}">
-                <a16:creationId xmlns:a16="http://schemas.microsoft.com/office/drawing/2014/main" id="{22A9B3C6-2D4E-4AAE-8B2B-7FB8866F9C93}"/>
+                <a16:creationId xmlns:a16="http://schemas.microsoft.com/office/drawing/2014/main" id="{D31BBFA3-9D48-4886-B1EE-7BDC8D27BF62}"/>
               </a:ext>
             </a:extLst>
           </p:cNvPr>
@@ -7008,7 +7008,7 @@
           <p:cNvPr id="5" name="Freeform 5">
             <a:extLst xmlns:a="http://schemas.openxmlformats.org/drawingml/2006/main">
               <a:ext uri="{FF2B5EF4-FFF2-40B4-BE49-F238E27FC236}">
-                <a16:creationId xmlns:a16="http://schemas.microsoft.com/office/drawing/2014/main" id="{AAAA0E0B-CE4C-439E-998E-AEFB91706710}"/>
+                <a16:creationId xmlns:a16="http://schemas.microsoft.com/office/drawing/2014/main" id="{FB16DC9F-2CDF-4795-B94C-42860E49CA3E}"/>
               </a:ext>
             </a:extLst>
           </p:cNvPr>
@@ -7046,10 +7046,10 @@
             </a:pathLst>
           </a:custGeom>
           <a:blipFill xmlns:a="http://schemas.openxmlformats.org/drawingml/2006/main">
-            <a:blip xmlns:r="http://schemas.openxmlformats.org/officeDocument/2006/relationships" r:embed="R8fe7dbea331a426a">
+            <a:blip xmlns:r="http://schemas.openxmlformats.org/officeDocument/2006/relationships" r:embed="Rf825c0ef26134221">
               <a:extLst>
                 <a:ext uri="{96DAC541-7B7A-43D3-8B79-37D633B846F1}">
-                  <asvg:svgBlip xmlns:asvg="http://schemas.microsoft.com/office/drawing/2016/SVG/main" r:embed="R73cbbf663b1b4bf6"/>
+                  <asvg:svgBlip xmlns:asvg="http://schemas.microsoft.com/office/drawing/2016/SVG/main" r:embed="R46acb274a6f3425e"/>
                 </a:ext>
               </a:extLst>
             </a:blip>
@@ -7071,7 +7071,7 @@
           <p:cNvPr id="6" name="TextBox 6">
             <a:extLst xmlns:a="http://schemas.openxmlformats.org/drawingml/2006/main">
               <a:ext uri="{FF2B5EF4-FFF2-40B4-BE49-F238E27FC236}">
-                <a16:creationId xmlns:a16="http://schemas.microsoft.com/office/drawing/2014/main" id="{2018A3A8-7D40-4048-9395-2EE85B6DF547}"/>
+                <a16:creationId xmlns:a16="http://schemas.microsoft.com/office/drawing/2014/main" id="{E8AE9FE6-FEC3-48D2-A2AA-C943AF6F7117}"/>
               </a:ext>
             </a:extLst>
           </p:cNvPr>
@@ -7123,7 +7123,7 @@
           <p:cNvPr id="7" name="">
             <a:extLst xmlns:a="http://schemas.openxmlformats.org/drawingml/2006/main">
               <a:ext uri="{FF2B5EF4-FFF2-40B4-BE49-F238E27FC236}">
-                <a16:creationId xmlns:a16="http://schemas.microsoft.com/office/drawing/2014/main" id="{93AA0EFE-886F-4297-B83D-0B37C8B08CFA}"/>
+                <a16:creationId xmlns:a16="http://schemas.microsoft.com/office/drawing/2014/main" id="{683A0A27-60F9-470A-8D52-B7EBAC497D67}"/>
               </a:ext>
             </a:extLst>
           </p:cNvPr>
@@ -7155,7 +7155,7 @@
           <p:cNvPr id="8" name="">
             <a:extLst xmlns:a="http://schemas.openxmlformats.org/drawingml/2006/main">
               <a:ext uri="{FF2B5EF4-FFF2-40B4-BE49-F238E27FC236}">
-                <a16:creationId xmlns:a16="http://schemas.microsoft.com/office/drawing/2014/main" id="{8743840B-EDEA-413B-81D7-51345E86BA60}"/>
+                <a16:creationId xmlns:a16="http://schemas.microsoft.com/office/drawing/2014/main" id="{298DDCB6-CF43-471C-822F-65727E3303D3}"/>
               </a:ext>
             </a:extLst>
           </p:cNvPr>
@@ -7185,7 +7185,7 @@
           <p:cNvPr id="9" name="">
             <a:extLst xmlns:a="http://schemas.openxmlformats.org/drawingml/2006/main">
               <a:ext uri="{FF2B5EF4-FFF2-40B4-BE49-F238E27FC236}">
-                <a16:creationId xmlns:a16="http://schemas.microsoft.com/office/drawing/2014/main" id="{075F1DE3-3E14-439A-9984-FA9BB648145E}"/>
+                <a16:creationId xmlns:a16="http://schemas.microsoft.com/office/drawing/2014/main" id="{E5BD7E81-BBE2-4853-A11E-B8E08F5ADD0F}"/>
               </a:ext>
             </a:extLst>
           </p:cNvPr>
@@ -7316,7 +7316,7 @@
           <p:cNvPr id="10" name="">
             <a:extLst xmlns:a="http://schemas.openxmlformats.org/drawingml/2006/main">
               <a:ext uri="{FF2B5EF4-FFF2-40B4-BE49-F238E27FC236}">
-                <a16:creationId xmlns:a16="http://schemas.microsoft.com/office/drawing/2014/main" id="{BF2FD60F-6E1C-4DEE-B0C0-041E787ADDF0}"/>
+                <a16:creationId xmlns:a16="http://schemas.microsoft.com/office/drawing/2014/main" id="{1975CDC0-E7A0-4008-B11D-D523E5ADABA5}"/>
               </a:ext>
             </a:extLst>
           </p:cNvPr>
@@ -7348,7 +7348,7 @@
           <p:cNvPr id="11" name="">
             <a:extLst xmlns:a="http://schemas.openxmlformats.org/drawingml/2006/main">
               <a:ext uri="{FF2B5EF4-FFF2-40B4-BE49-F238E27FC236}">
-                <a16:creationId xmlns:a16="http://schemas.microsoft.com/office/drawing/2014/main" id="{A5A19A74-6A88-400F-B960-AD2F4E67E47E}"/>
+                <a16:creationId xmlns:a16="http://schemas.microsoft.com/office/drawing/2014/main" id="{43951D2E-2993-4767-9EAB-517716D1F757}"/>
               </a:ext>
             </a:extLst>
           </p:cNvPr>
@@ -7378,7 +7378,7 @@
           <p:cNvPr id="12" name="">
             <a:extLst xmlns:a="http://schemas.openxmlformats.org/drawingml/2006/main">
               <a:ext uri="{FF2B5EF4-FFF2-40B4-BE49-F238E27FC236}">
-                <a16:creationId xmlns:a16="http://schemas.microsoft.com/office/drawing/2014/main" id="{730FF4A4-D7D0-4B90-8271-B58483231DB8}"/>
+                <a16:creationId xmlns:a16="http://schemas.microsoft.com/office/drawing/2014/main" id="{60C9708F-A558-419D-99D6-FACE71141568}"/>
               </a:ext>
             </a:extLst>
           </p:cNvPr>
@@ -7463,7 +7463,7 @@
           <p:cNvPr id="13" name="">
             <a:extLst xmlns:a="http://schemas.openxmlformats.org/drawingml/2006/main">
               <a:ext uri="{FF2B5EF4-FFF2-40B4-BE49-F238E27FC236}">
-                <a16:creationId xmlns:a16="http://schemas.microsoft.com/office/drawing/2014/main" id="{C64E1714-F470-4350-99EA-F80D2ECB651F}"/>
+                <a16:creationId xmlns:a16="http://schemas.microsoft.com/office/drawing/2014/main" id="{A5A7C97D-D8AD-497C-A22C-3A5B17477CA4}"/>
               </a:ext>
             </a:extLst>
           </p:cNvPr>
@@ -7518,7 +7518,7 @@
     </p:spTree>
     <p:extLst>
       <p:ext uri="{BB962C8B-B14F-4D97-AF65-F5344CB8AC3E}">
-        <p14:creationId xmlns:p14="http://schemas.microsoft.com/office/powerpoint/2010/main" val="925023903"/>
+        <p14:creationId xmlns:p14="http://schemas.microsoft.com/office/powerpoint/2010/main" val="2024930356"/>
       </p:ext>
     </p:extLst>
   </p:cSld>
@@ -7549,7 +7549,7 @@
           <p:cNvPr id="3" name="Freeform 3">
             <a:extLst xmlns:a="http://schemas.openxmlformats.org/drawingml/2006/main">
               <a:ext uri="{FF2B5EF4-FFF2-40B4-BE49-F238E27FC236}">
-                <a16:creationId xmlns:a16="http://schemas.microsoft.com/office/drawing/2014/main" id="{175CA0A9-491C-4267-AAB3-A5B735C9E938}"/>
+                <a16:creationId xmlns:a16="http://schemas.microsoft.com/office/drawing/2014/main" id="{7A3204C4-A59A-43A8-BB85-BB97724891B4}"/>
               </a:ext>
             </a:extLst>
           </p:cNvPr>
@@ -7612,7 +7612,7 @@
           <p:cNvPr id="4" name="TextBox 4">
             <a:extLst xmlns:a="http://schemas.openxmlformats.org/drawingml/2006/main">
               <a:ext uri="{FF2B5EF4-FFF2-40B4-BE49-F238E27FC236}">
-                <a16:creationId xmlns:a16="http://schemas.microsoft.com/office/drawing/2014/main" id="{AC2834BC-32B1-4528-803D-BA562AF4E7CF}"/>
+                <a16:creationId xmlns:a16="http://schemas.microsoft.com/office/drawing/2014/main" id="{551D4260-09FB-4D51-B6EC-1720B3E5B749}"/>
               </a:ext>
             </a:extLst>
           </p:cNvPr>
@@ -7649,7 +7649,7 @@
           <p:cNvPr id="5" name="TextBox 5">
             <a:extLst xmlns:a="http://schemas.openxmlformats.org/drawingml/2006/main">
               <a:ext uri="{FF2B5EF4-FFF2-40B4-BE49-F238E27FC236}">
-                <a16:creationId xmlns:a16="http://schemas.microsoft.com/office/drawing/2014/main" id="{FA85934A-82BE-4BB5-9BA3-FFB5C486CD01}"/>
+                <a16:creationId xmlns:a16="http://schemas.microsoft.com/office/drawing/2014/main" id="{EF40686F-B33D-4F56-BAE9-FDE7BB2494D6}"/>
               </a:ext>
             </a:extLst>
           </p:cNvPr>
@@ -7701,7 +7701,7 @@
           <p:cNvPr id="6" name="">
             <a:extLst xmlns:a="http://schemas.openxmlformats.org/drawingml/2006/main">
               <a:ext uri="{FF2B5EF4-FFF2-40B4-BE49-F238E27FC236}">
-                <a16:creationId xmlns:a16="http://schemas.microsoft.com/office/drawing/2014/main" id="{09038487-9EC8-4B8C-B71C-3D5516F09DCC}"/>
+                <a16:creationId xmlns:a16="http://schemas.microsoft.com/office/drawing/2014/main" id="{6799DA1C-1122-49D3-9E4B-F44FB46C93BA}"/>
               </a:ext>
             </a:extLst>
           </p:cNvPr>
@@ -7731,7 +7731,7 @@
           <p:cNvPr id="7" name="">
             <a:extLst xmlns:a="http://schemas.openxmlformats.org/drawingml/2006/main">
               <a:ext uri="{FF2B5EF4-FFF2-40B4-BE49-F238E27FC236}">
-                <a16:creationId xmlns:a16="http://schemas.microsoft.com/office/drawing/2014/main" id="{7AC9493C-3875-49BB-A4A5-B585342CE214}"/>
+                <a16:creationId xmlns:a16="http://schemas.microsoft.com/office/drawing/2014/main" id="{1774B553-F088-4D09-9B1B-A75DCDFED756}"/>
               </a:ext>
             </a:extLst>
           </p:cNvPr>
@@ -7788,7 +7788,7 @@
           <p:cNvPr id="8" name="">
             <a:extLst xmlns:a="http://schemas.openxmlformats.org/drawingml/2006/main">
               <a:ext uri="{FF2B5EF4-FFF2-40B4-BE49-F238E27FC236}">
-                <a16:creationId xmlns:a16="http://schemas.microsoft.com/office/drawing/2014/main" id="{0E96DBE3-8470-41B3-A1D8-4F42F94A6211}"/>
+                <a16:creationId xmlns:a16="http://schemas.microsoft.com/office/drawing/2014/main" id="{3E5D1A13-6533-47CA-952D-B0B1D39CE3BC}"/>
               </a:ext>
             </a:extLst>
           </p:cNvPr>
@@ -7818,7 +7818,7 @@
           <p:cNvPr id="9" name="">
             <a:extLst xmlns:a="http://schemas.openxmlformats.org/drawingml/2006/main">
               <a:ext uri="{FF2B5EF4-FFF2-40B4-BE49-F238E27FC236}">
-                <a16:creationId xmlns:a16="http://schemas.microsoft.com/office/drawing/2014/main" id="{E41E98BC-05DE-4E68-840A-9787C6975FCA}"/>
+                <a16:creationId xmlns:a16="http://schemas.microsoft.com/office/drawing/2014/main" id="{ACC0AF4A-1BEC-44AC-8993-338605948460}"/>
               </a:ext>
             </a:extLst>
           </p:cNvPr>
@@ -7875,7 +7875,7 @@
           <p:cNvPr id="10" name="">
             <a:extLst xmlns:a="http://schemas.openxmlformats.org/drawingml/2006/main">
               <a:ext uri="{FF2B5EF4-FFF2-40B4-BE49-F238E27FC236}">
-                <a16:creationId xmlns:a16="http://schemas.microsoft.com/office/drawing/2014/main" id="{4A3688DE-A77D-4BE5-A892-62D89FDC823F}"/>
+                <a16:creationId xmlns:a16="http://schemas.microsoft.com/office/drawing/2014/main" id="{7764D39C-F203-4826-BFB5-819E4DF5954A}"/>
               </a:ext>
             </a:extLst>
           </p:cNvPr>
@@ -7905,7 +7905,7 @@
           <p:cNvPr id="11" name="">
             <a:extLst xmlns:a="http://schemas.openxmlformats.org/drawingml/2006/main">
               <a:ext uri="{FF2B5EF4-FFF2-40B4-BE49-F238E27FC236}">
-                <a16:creationId xmlns:a16="http://schemas.microsoft.com/office/drawing/2014/main" id="{85F0A006-1041-450C-BB40-8421A5FDE8B8}"/>
+                <a16:creationId xmlns:a16="http://schemas.microsoft.com/office/drawing/2014/main" id="{14922C2F-008C-4182-86D4-5AF275BE9EB3}"/>
               </a:ext>
             </a:extLst>
           </p:cNvPr>
@@ -7962,7 +7962,7 @@
           <p:cNvPr id="12" name="">
             <a:extLst xmlns:a="http://schemas.openxmlformats.org/drawingml/2006/main">
               <a:ext uri="{FF2B5EF4-FFF2-40B4-BE49-F238E27FC236}">
-                <a16:creationId xmlns:a16="http://schemas.microsoft.com/office/drawing/2014/main" id="{47124770-6875-4A49-8C74-1137C60EE078}"/>
+                <a16:creationId xmlns:a16="http://schemas.microsoft.com/office/drawing/2014/main" id="{E71F1274-002A-471E-9EE2-868E2F5D3BB4}"/>
               </a:ext>
             </a:extLst>
           </p:cNvPr>
@@ -7992,7 +7992,7 @@
           <p:cNvPr id="13" name="">
             <a:extLst xmlns:a="http://schemas.openxmlformats.org/drawingml/2006/main">
               <a:ext uri="{FF2B5EF4-FFF2-40B4-BE49-F238E27FC236}">
-                <a16:creationId xmlns:a16="http://schemas.microsoft.com/office/drawing/2014/main" id="{1511E754-7A40-450A-95F8-EC92D4C61D2C}"/>
+                <a16:creationId xmlns:a16="http://schemas.microsoft.com/office/drawing/2014/main" id="{586CCFA5-A421-4BA8-8D3E-8467207CD86B}"/>
               </a:ext>
             </a:extLst>
           </p:cNvPr>
@@ -8049,7 +8049,7 @@
           <p:cNvPr id="14" name="">
             <a:extLst xmlns:a="http://schemas.openxmlformats.org/drawingml/2006/main">
               <a:ext uri="{FF2B5EF4-FFF2-40B4-BE49-F238E27FC236}">
-                <a16:creationId xmlns:a16="http://schemas.microsoft.com/office/drawing/2014/main" id="{03F26F47-2880-470A-92F8-F8E3243CCCEE}"/>
+                <a16:creationId xmlns:a16="http://schemas.microsoft.com/office/drawing/2014/main" id="{AF0AB055-5CA5-4E6D-BB9A-68F73916E7B6}"/>
               </a:ext>
             </a:extLst>
           </p:cNvPr>
@@ -8104,7 +8104,7 @@
     </p:spTree>
     <p:extLst>
       <p:ext uri="{BB962C8B-B14F-4D97-AF65-F5344CB8AC3E}">
-        <p14:creationId xmlns:p14="http://schemas.microsoft.com/office/powerpoint/2010/main" val="1267795750"/>
+        <p14:creationId xmlns:p14="http://schemas.microsoft.com/office/powerpoint/2010/main" val="1870981853"/>
       </p:ext>
     </p:extLst>
   </p:cSld>
@@ -8135,7 +8135,7 @@
           <p:cNvPr id="3" name="Freeform 3">
             <a:extLst xmlns:a="http://schemas.openxmlformats.org/drawingml/2006/main">
               <a:ext uri="{FF2B5EF4-FFF2-40B4-BE49-F238E27FC236}">
-                <a16:creationId xmlns:a16="http://schemas.microsoft.com/office/drawing/2014/main" id="{1B45A037-E7F3-4462-940E-8D3E513F218A}"/>
+                <a16:creationId xmlns:a16="http://schemas.microsoft.com/office/drawing/2014/main" id="{ACEBC7DD-DEA4-4076-B684-79208567B909}"/>
               </a:ext>
             </a:extLst>
           </p:cNvPr>
@@ -8198,7 +8198,7 @@
           <p:cNvPr id="4" name="TextBox 4">
             <a:extLst xmlns:a="http://schemas.openxmlformats.org/drawingml/2006/main">
               <a:ext uri="{FF2B5EF4-FFF2-40B4-BE49-F238E27FC236}">
-                <a16:creationId xmlns:a16="http://schemas.microsoft.com/office/drawing/2014/main" id="{17476C0D-557A-4769-BB15-264E4441B11A}"/>
+                <a16:creationId xmlns:a16="http://schemas.microsoft.com/office/drawing/2014/main" id="{97413F95-CE55-4E79-8E18-D6B5FB41DC82}"/>
               </a:ext>
             </a:extLst>
           </p:cNvPr>
@@ -8235,7 +8235,7 @@
           <p:cNvPr id="5" name="TextBox 5">
             <a:extLst xmlns:a="http://schemas.openxmlformats.org/drawingml/2006/main">
               <a:ext uri="{FF2B5EF4-FFF2-40B4-BE49-F238E27FC236}">
-                <a16:creationId xmlns:a16="http://schemas.microsoft.com/office/drawing/2014/main" id="{F63740CD-AEAC-42A6-9263-812DEC08F617}"/>
+                <a16:creationId xmlns:a16="http://schemas.microsoft.com/office/drawing/2014/main" id="{F383ABD9-8DC7-4B8A-863A-4DA52DEBE6EB}"/>
               </a:ext>
             </a:extLst>
           </p:cNvPr>
@@ -8287,7 +8287,7 @@
           <p:cNvPr id="7" name="Freeform 7">
             <a:extLst xmlns:a="http://schemas.openxmlformats.org/drawingml/2006/main">
               <a:ext uri="{FF2B5EF4-FFF2-40B4-BE49-F238E27FC236}">
-                <a16:creationId xmlns:a16="http://schemas.microsoft.com/office/drawing/2014/main" id="{10C48DF5-5A33-4CC0-923D-7EBAFDD7121D}"/>
+                <a16:creationId xmlns:a16="http://schemas.microsoft.com/office/drawing/2014/main" id="{54792D80-933C-47F8-B73F-5AE7F48CEC21}"/>
               </a:ext>
             </a:extLst>
           </p:cNvPr>
@@ -8325,10 +8325,10 @@
             </a:pathLst>
           </a:custGeom>
           <a:blipFill xmlns:a="http://schemas.openxmlformats.org/drawingml/2006/main">
-            <a:blip xmlns:r="http://schemas.openxmlformats.org/officeDocument/2006/relationships" r:embed="R15ca1cacfaae4446">
+            <a:blip xmlns:r="http://schemas.openxmlformats.org/officeDocument/2006/relationships" r:embed="R034c82f6959f4760">
               <a:extLst>
                 <a:ext uri="{96DAC541-7B7A-43D3-8B79-37D633B846F1}">
-                  <asvg:svgBlip xmlns:asvg="http://schemas.microsoft.com/office/drawing/2016/SVG/main" r:embed="R3feb26d9e61b444b"/>
+                  <asvg:svgBlip xmlns:asvg="http://schemas.microsoft.com/office/drawing/2016/SVG/main" r:embed="R6fd610d47ee0403d"/>
                 </a:ext>
               </a:extLst>
             </a:blip>
@@ -8350,7 +8350,7 @@
           <p:cNvPr id="8" name="">
             <a:extLst xmlns:a="http://schemas.openxmlformats.org/drawingml/2006/main">
               <a:ext uri="{FF2B5EF4-FFF2-40B4-BE49-F238E27FC236}">
-                <a16:creationId xmlns:a16="http://schemas.microsoft.com/office/drawing/2014/main" id="{C6305807-7A82-411E-AEDC-2D5175764857}"/>
+                <a16:creationId xmlns:a16="http://schemas.microsoft.com/office/drawing/2014/main" id="{A8026CE0-7945-4756-A183-1EBA3318850A}"/>
               </a:ext>
             </a:extLst>
           </p:cNvPr>
@@ -8380,7 +8380,7 @@
           <p:cNvPr id="9" name="">
             <a:extLst xmlns:a="http://schemas.openxmlformats.org/drawingml/2006/main">
               <a:ext uri="{FF2B5EF4-FFF2-40B4-BE49-F238E27FC236}">
-                <a16:creationId xmlns:a16="http://schemas.microsoft.com/office/drawing/2014/main" id="{BD75ECDD-A870-439D-B42D-DD76B09AFA5A}"/>
+                <a16:creationId xmlns:a16="http://schemas.microsoft.com/office/drawing/2014/main" id="{A06E1AAD-6A1A-4585-B6E7-D6626AE518DD}"/>
               </a:ext>
             </a:extLst>
           </p:cNvPr>
@@ -8437,7 +8437,7 @@
           <p:cNvPr id="10" name="">
             <a:extLst xmlns:a="http://schemas.openxmlformats.org/drawingml/2006/main">
               <a:ext uri="{FF2B5EF4-FFF2-40B4-BE49-F238E27FC236}">
-                <a16:creationId xmlns:a16="http://schemas.microsoft.com/office/drawing/2014/main" id="{C0141FB3-C8EF-4D54-B7D8-C86E95C441F2}"/>
+                <a16:creationId xmlns:a16="http://schemas.microsoft.com/office/drawing/2014/main" id="{8CC993F1-0AD9-4A69-983E-B03C721CB585}"/>
               </a:ext>
             </a:extLst>
           </p:cNvPr>
@@ -8467,7 +8467,7 @@
           <p:cNvPr id="11" name="">
             <a:extLst xmlns:a="http://schemas.openxmlformats.org/drawingml/2006/main">
               <a:ext uri="{FF2B5EF4-FFF2-40B4-BE49-F238E27FC236}">
-                <a16:creationId xmlns:a16="http://schemas.microsoft.com/office/drawing/2014/main" id="{50A9371E-DC4F-4029-8AAD-16188DA8062C}"/>
+                <a16:creationId xmlns:a16="http://schemas.microsoft.com/office/drawing/2014/main" id="{67DE71AF-7F4E-436C-8BE1-31CDF5C9E84E}"/>
               </a:ext>
             </a:extLst>
           </p:cNvPr>
@@ -8524,7 +8524,7 @@
           <p:cNvPr id="12" name="">
             <a:extLst xmlns:a="http://schemas.openxmlformats.org/drawingml/2006/main">
               <a:ext uri="{FF2B5EF4-FFF2-40B4-BE49-F238E27FC236}">
-                <a16:creationId xmlns:a16="http://schemas.microsoft.com/office/drawing/2014/main" id="{8E2005ED-D589-4823-B7A6-8DA137606EA6}"/>
+                <a16:creationId xmlns:a16="http://schemas.microsoft.com/office/drawing/2014/main" id="{BDE665F8-70EC-4FBE-8C70-2FADDB490A69}"/>
               </a:ext>
             </a:extLst>
           </p:cNvPr>
@@ -8554,7 +8554,7 @@
           <p:cNvPr id="13" name="">
             <a:extLst xmlns:a="http://schemas.openxmlformats.org/drawingml/2006/main">
               <a:ext uri="{FF2B5EF4-FFF2-40B4-BE49-F238E27FC236}">
-                <a16:creationId xmlns:a16="http://schemas.microsoft.com/office/drawing/2014/main" id="{F404699E-FE28-4C09-B0AB-DD258EF71183}"/>
+                <a16:creationId xmlns:a16="http://schemas.microsoft.com/office/drawing/2014/main" id="{AF57171F-63B9-4F5B-8F36-883944155605}"/>
               </a:ext>
             </a:extLst>
           </p:cNvPr>
@@ -8609,7 +8609,7 @@
     </p:spTree>
     <p:extLst>
       <p:ext uri="{BB962C8B-B14F-4D97-AF65-F5344CB8AC3E}">
-        <p14:creationId xmlns:p14="http://schemas.microsoft.com/office/powerpoint/2010/main" val="2094642403"/>
+        <p14:creationId xmlns:p14="http://schemas.microsoft.com/office/powerpoint/2010/main" val="2080214290"/>
       </p:ext>
     </p:extLst>
   </p:cSld>
@@ -8640,7 +8640,7 @@
           <p:cNvPr id="3" name="Freeform 3">
             <a:extLst xmlns:a="http://schemas.openxmlformats.org/drawingml/2006/main">
               <a:ext uri="{FF2B5EF4-FFF2-40B4-BE49-F238E27FC236}">
-                <a16:creationId xmlns:a16="http://schemas.microsoft.com/office/drawing/2014/main" id="{47FCACFE-B2D2-4FC4-BF99-A16DF6161749}"/>
+                <a16:creationId xmlns:a16="http://schemas.microsoft.com/office/drawing/2014/main" id="{27BA77C9-CC04-4D5C-A35D-30BC1A1DE80A}"/>
               </a:ext>
             </a:extLst>
           </p:cNvPr>
@@ -8703,7 +8703,7 @@
           <p:cNvPr id="4" name="TextBox 4">
             <a:extLst xmlns:a="http://schemas.openxmlformats.org/drawingml/2006/main">
               <a:ext uri="{FF2B5EF4-FFF2-40B4-BE49-F238E27FC236}">
-                <a16:creationId xmlns:a16="http://schemas.microsoft.com/office/drawing/2014/main" id="{F95BAE8C-CCF0-433F-B565-CB6E9534377D}"/>
+                <a16:creationId xmlns:a16="http://schemas.microsoft.com/office/drawing/2014/main" id="{4A459E2F-E17C-4FF1-AE5E-410DF2D9B4C4}"/>
               </a:ext>
             </a:extLst>
           </p:cNvPr>
@@ -8740,7 +8740,7 @@
           <p:cNvPr id="5" name="TextBox 5">
             <a:extLst xmlns:a="http://schemas.openxmlformats.org/drawingml/2006/main">
               <a:ext uri="{FF2B5EF4-FFF2-40B4-BE49-F238E27FC236}">
-                <a16:creationId xmlns:a16="http://schemas.microsoft.com/office/drawing/2014/main" id="{365350BC-F5AA-4369-94E2-1CC9D2086628}"/>
+                <a16:creationId xmlns:a16="http://schemas.microsoft.com/office/drawing/2014/main" id="{8F1CEB48-03D0-44B3-A660-D47B30C92143}"/>
               </a:ext>
             </a:extLst>
           </p:cNvPr>
@@ -8792,7 +8792,7 @@
           <p:cNvPr id="6" name="TextBox 6">
             <a:extLst xmlns:a="http://schemas.openxmlformats.org/drawingml/2006/main">
               <a:ext uri="{FF2B5EF4-FFF2-40B4-BE49-F238E27FC236}">
-                <a16:creationId xmlns:a16="http://schemas.microsoft.com/office/drawing/2014/main" id="{F95367E2-8386-4059-B860-64808D12AF24}"/>
+                <a16:creationId xmlns:a16="http://schemas.microsoft.com/office/drawing/2014/main" id="{7FA249DA-4C60-4585-84C6-E1D15650EF78}"/>
               </a:ext>
             </a:extLst>
           </p:cNvPr>
@@ -8838,7 +8838,7 @@
           <p:cNvPr id="7" name="Freeform 7">
             <a:extLst xmlns:a="http://schemas.openxmlformats.org/drawingml/2006/main">
               <a:ext uri="{FF2B5EF4-FFF2-40B4-BE49-F238E27FC236}">
-                <a16:creationId xmlns:a16="http://schemas.microsoft.com/office/drawing/2014/main" id="{62B62D16-D2F8-4A9A-957C-126A416ED551}"/>
+                <a16:creationId xmlns:a16="http://schemas.microsoft.com/office/drawing/2014/main" id="{06F0DDC7-F8C5-472C-8278-D88348DECB8F}"/>
               </a:ext>
             </a:extLst>
           </p:cNvPr>
@@ -8876,10 +8876,10 @@
             </a:pathLst>
           </a:custGeom>
           <a:blipFill xmlns:a="http://schemas.openxmlformats.org/drawingml/2006/main">
-            <a:blip xmlns:r="http://schemas.openxmlformats.org/officeDocument/2006/relationships" r:embed="R006dee6a79e6499f">
+            <a:blip xmlns:r="http://schemas.openxmlformats.org/officeDocument/2006/relationships" r:embed="Rc1a9253d6a6147e0">
               <a:extLst>
                 <a:ext uri="{96DAC541-7B7A-43D3-8B79-37D633B846F1}">
-                  <asvg:svgBlip xmlns:asvg="http://schemas.microsoft.com/office/drawing/2016/SVG/main" r:embed="Ra0b73cf015604f47"/>
+                  <asvg:svgBlip xmlns:asvg="http://schemas.microsoft.com/office/drawing/2016/SVG/main" r:embed="Rdd212d8166db4ed3"/>
                 </a:ext>
               </a:extLst>
             </a:blip>
@@ -8901,7 +8901,7 @@
           <p:cNvPr id="8" name="">
             <a:extLst xmlns:a="http://schemas.openxmlformats.org/drawingml/2006/main">
               <a:ext uri="{FF2B5EF4-FFF2-40B4-BE49-F238E27FC236}">
-                <a16:creationId xmlns:a16="http://schemas.microsoft.com/office/drawing/2014/main" id="{84BAB5B6-1811-4057-895B-F369403F280F}"/>
+                <a16:creationId xmlns:a16="http://schemas.microsoft.com/office/drawing/2014/main" id="{50DB572D-097A-4A84-9D4C-D119F4D890F6}"/>
               </a:ext>
             </a:extLst>
           </p:cNvPr>
@@ -8931,7 +8931,7 @@
           <p:cNvPr id="9" name="">
             <a:extLst xmlns:a="http://schemas.openxmlformats.org/drawingml/2006/main">
               <a:ext uri="{FF2B5EF4-FFF2-40B4-BE49-F238E27FC236}">
-                <a16:creationId xmlns:a16="http://schemas.microsoft.com/office/drawing/2014/main" id="{F6E076B1-5288-4EAB-996F-B62B60A5FD3E}"/>
+                <a16:creationId xmlns:a16="http://schemas.microsoft.com/office/drawing/2014/main" id="{72B8B296-B3F9-4E6A-B961-873E9134A1F4}"/>
               </a:ext>
             </a:extLst>
           </p:cNvPr>
@@ -8988,7 +8988,7 @@
           <p:cNvPr id="10" name="">
             <a:extLst xmlns:a="http://schemas.openxmlformats.org/drawingml/2006/main">
               <a:ext uri="{FF2B5EF4-FFF2-40B4-BE49-F238E27FC236}">
-                <a16:creationId xmlns:a16="http://schemas.microsoft.com/office/drawing/2014/main" id="{3FD27507-8D8B-4242-9FFC-EFB477F8E248}"/>
+                <a16:creationId xmlns:a16="http://schemas.microsoft.com/office/drawing/2014/main" id="{94A5ED4C-79D9-4CCE-A921-1ADF8980817D}"/>
               </a:ext>
             </a:extLst>
           </p:cNvPr>
@@ -9018,7 +9018,7 @@
           <p:cNvPr id="11" name="">
             <a:extLst xmlns:a="http://schemas.openxmlformats.org/drawingml/2006/main">
               <a:ext uri="{FF2B5EF4-FFF2-40B4-BE49-F238E27FC236}">
-                <a16:creationId xmlns:a16="http://schemas.microsoft.com/office/drawing/2014/main" id="{FF93BCB9-3B8A-4441-951D-4ABDA9000401}"/>
+                <a16:creationId xmlns:a16="http://schemas.microsoft.com/office/drawing/2014/main" id="{113E9A3F-A4BD-4196-93C3-CCAE5133DAE5}"/>
               </a:ext>
             </a:extLst>
           </p:cNvPr>
@@ -9075,7 +9075,7 @@
           <p:cNvPr id="12" name="">
             <a:extLst xmlns:a="http://schemas.openxmlformats.org/drawingml/2006/main">
               <a:ext uri="{FF2B5EF4-FFF2-40B4-BE49-F238E27FC236}">
-                <a16:creationId xmlns:a16="http://schemas.microsoft.com/office/drawing/2014/main" id="{FB495C16-648B-4859-98BA-B8D51DA7C8DF}"/>
+                <a16:creationId xmlns:a16="http://schemas.microsoft.com/office/drawing/2014/main" id="{CB60B900-5D02-4DCE-B61D-215D7A8B5198}"/>
               </a:ext>
             </a:extLst>
           </p:cNvPr>
@@ -9105,7 +9105,7 @@
           <p:cNvPr id="13" name="">
             <a:extLst xmlns:a="http://schemas.openxmlformats.org/drawingml/2006/main">
               <a:ext uri="{FF2B5EF4-FFF2-40B4-BE49-F238E27FC236}">
-                <a16:creationId xmlns:a16="http://schemas.microsoft.com/office/drawing/2014/main" id="{4BB5DB45-720C-439E-A5E2-9E1EE46EE64B}"/>
+                <a16:creationId xmlns:a16="http://schemas.microsoft.com/office/drawing/2014/main" id="{B809F56F-E093-4A47-8DD4-A17739F1B7D1}"/>
               </a:ext>
             </a:extLst>
           </p:cNvPr>
@@ -9162,7 +9162,7 @@
           <p:cNvPr id="14" name="">
             <a:extLst xmlns:a="http://schemas.openxmlformats.org/drawingml/2006/main">
               <a:ext uri="{FF2B5EF4-FFF2-40B4-BE49-F238E27FC236}">
-                <a16:creationId xmlns:a16="http://schemas.microsoft.com/office/drawing/2014/main" id="{86FEB9BC-00E7-4312-8933-B7595F824DA2}"/>
+                <a16:creationId xmlns:a16="http://schemas.microsoft.com/office/drawing/2014/main" id="{1B267695-D834-4399-80F0-956735B29887}"/>
               </a:ext>
             </a:extLst>
           </p:cNvPr>
@@ -9192,7 +9192,7 @@
           <p:cNvPr id="15" name="">
             <a:extLst xmlns:a="http://schemas.openxmlformats.org/drawingml/2006/main">
               <a:ext uri="{FF2B5EF4-FFF2-40B4-BE49-F238E27FC236}">
-                <a16:creationId xmlns:a16="http://schemas.microsoft.com/office/drawing/2014/main" id="{8C13D58B-E09A-4D1A-B17D-5A48D116FF80}"/>
+                <a16:creationId xmlns:a16="http://schemas.microsoft.com/office/drawing/2014/main" id="{989EEA55-6B52-46B2-9D52-59005A5098FB}"/>
               </a:ext>
             </a:extLst>
           </p:cNvPr>
@@ -9247,7 +9247,7 @@
     </p:spTree>
     <p:extLst>
       <p:ext uri="{BB962C8B-B14F-4D97-AF65-F5344CB8AC3E}">
-        <p14:creationId xmlns:p14="http://schemas.microsoft.com/office/powerpoint/2010/main" val="2105524202"/>
+        <p14:creationId xmlns:p14="http://schemas.microsoft.com/office/powerpoint/2010/main" val="896479376"/>
       </p:ext>
     </p:extLst>
   </p:cSld>
@@ -9278,7 +9278,7 @@
           <p:cNvPr id="3" name="Freeform 3">
             <a:extLst xmlns:a="http://schemas.openxmlformats.org/drawingml/2006/main">
               <a:ext uri="{FF2B5EF4-FFF2-40B4-BE49-F238E27FC236}">
-                <a16:creationId xmlns:a16="http://schemas.microsoft.com/office/drawing/2014/main" id="{9E8B3CFB-AF41-4C63-8CC8-B00E7E4506A8}"/>
+                <a16:creationId xmlns:a16="http://schemas.microsoft.com/office/drawing/2014/main" id="{754B1E3C-AE03-45F4-8E59-4D9C52B4B42E}"/>
               </a:ext>
             </a:extLst>
           </p:cNvPr>
@@ -9341,7 +9341,7 @@
           <p:cNvPr id="4" name="TextBox 4">
             <a:extLst xmlns:a="http://schemas.openxmlformats.org/drawingml/2006/main">
               <a:ext uri="{FF2B5EF4-FFF2-40B4-BE49-F238E27FC236}">
-                <a16:creationId xmlns:a16="http://schemas.microsoft.com/office/drawing/2014/main" id="{3164802C-52F9-4D9D-B685-57740430DC02}"/>
+                <a16:creationId xmlns:a16="http://schemas.microsoft.com/office/drawing/2014/main" id="{7822D4FF-9B4F-4144-9DB0-CAF35510BCD6}"/>
               </a:ext>
             </a:extLst>
           </p:cNvPr>
@@ -9378,7 +9378,7 @@
           <p:cNvPr id="5" name="TextBox 5">
             <a:extLst xmlns:a="http://schemas.openxmlformats.org/drawingml/2006/main">
               <a:ext uri="{FF2B5EF4-FFF2-40B4-BE49-F238E27FC236}">
-                <a16:creationId xmlns:a16="http://schemas.microsoft.com/office/drawing/2014/main" id="{0B0DA094-65FA-472F-8D68-A4E598D47ECD}"/>
+                <a16:creationId xmlns:a16="http://schemas.microsoft.com/office/drawing/2014/main" id="{BEA96763-498E-4D22-B351-4FD7F4F9B184}"/>
               </a:ext>
             </a:extLst>
           </p:cNvPr>
@@ -9464,7 +9464,7 @@
           <p:cNvPr id="7" name="">
             <a:extLst xmlns:a="http://schemas.openxmlformats.org/drawingml/2006/main">
               <a:ext uri="{FF2B5EF4-FFF2-40B4-BE49-F238E27FC236}">
-                <a16:creationId xmlns:a16="http://schemas.microsoft.com/office/drawing/2014/main" id="{533BABC8-68CD-4863-B4CB-5027FB1A368C}"/>
+                <a16:creationId xmlns:a16="http://schemas.microsoft.com/office/drawing/2014/main" id="{F0184D06-5354-4261-BD7B-0CC4C5D0E997}"/>
               </a:ext>
             </a:extLst>
           </p:cNvPr>
@@ -9496,7 +9496,7 @@
           <p:cNvPr id="8" name="">
             <a:extLst xmlns:a="http://schemas.openxmlformats.org/drawingml/2006/main">
               <a:ext uri="{FF2B5EF4-FFF2-40B4-BE49-F238E27FC236}">
-                <a16:creationId xmlns:a16="http://schemas.microsoft.com/office/drawing/2014/main" id="{67B10B51-A946-482B-8EC8-5FA478012BF3}"/>
+                <a16:creationId xmlns:a16="http://schemas.microsoft.com/office/drawing/2014/main" id="{60C8FB89-ADE3-4292-AAB0-D624CA7C25F2}"/>
               </a:ext>
             </a:extLst>
           </p:cNvPr>
@@ -9526,7 +9526,7 @@
           <p:cNvPr id="9" name="">
             <a:extLst xmlns:a="http://schemas.openxmlformats.org/drawingml/2006/main">
               <a:ext uri="{FF2B5EF4-FFF2-40B4-BE49-F238E27FC236}">
-                <a16:creationId xmlns:a16="http://schemas.microsoft.com/office/drawing/2014/main" id="{6FB191F9-1074-44E0-A7A6-E1EEB2AD0F45}"/>
+                <a16:creationId xmlns:a16="http://schemas.microsoft.com/office/drawing/2014/main" id="{C4FC3D9B-D30B-4CF6-8C43-578210593FEF}"/>
               </a:ext>
             </a:extLst>
           </p:cNvPr>
@@ -9634,7 +9634,7 @@
           <p:cNvPr id="10" name="">
             <a:extLst xmlns:a="http://schemas.openxmlformats.org/drawingml/2006/main">
               <a:ext uri="{FF2B5EF4-FFF2-40B4-BE49-F238E27FC236}">
-                <a16:creationId xmlns:a16="http://schemas.microsoft.com/office/drawing/2014/main" id="{C0A21E4C-2B0B-41D4-B9F5-14E29DFB0400}"/>
+                <a16:creationId xmlns:a16="http://schemas.microsoft.com/office/drawing/2014/main" id="{DFE61F4D-E727-4835-9960-1775C23B33EB}"/>
               </a:ext>
             </a:extLst>
           </p:cNvPr>
@@ -9666,7 +9666,7 @@
           <p:cNvPr id="11" name="">
             <a:extLst xmlns:a="http://schemas.openxmlformats.org/drawingml/2006/main">
               <a:ext uri="{FF2B5EF4-FFF2-40B4-BE49-F238E27FC236}">
-                <a16:creationId xmlns:a16="http://schemas.microsoft.com/office/drawing/2014/main" id="{0D81813D-09BD-4369-B6A2-D3AFEE3BE282}"/>
+                <a16:creationId xmlns:a16="http://schemas.microsoft.com/office/drawing/2014/main" id="{C4DA8A30-FE37-4B91-BDE8-A3BFB1C8D769}"/>
               </a:ext>
             </a:extLst>
           </p:cNvPr>
@@ -9696,7 +9696,7 @@
           <p:cNvPr id="12" name="">
             <a:extLst xmlns:a="http://schemas.openxmlformats.org/drawingml/2006/main">
               <a:ext uri="{FF2B5EF4-FFF2-40B4-BE49-F238E27FC236}">
-                <a16:creationId xmlns:a16="http://schemas.microsoft.com/office/drawing/2014/main" id="{C63B0F65-BAAB-4B77-975E-A06950D7C46B}"/>
+                <a16:creationId xmlns:a16="http://schemas.microsoft.com/office/drawing/2014/main" id="{90699AAA-0976-4FCB-9F6C-C0D791E7F5C1}"/>
               </a:ext>
             </a:extLst>
           </p:cNvPr>
@@ -9804,7 +9804,7 @@
           <p:cNvPr id="13" name="">
             <a:extLst xmlns:a="http://schemas.openxmlformats.org/drawingml/2006/main">
               <a:ext uri="{FF2B5EF4-FFF2-40B4-BE49-F238E27FC236}">
-                <a16:creationId xmlns:a16="http://schemas.microsoft.com/office/drawing/2014/main" id="{146EF139-265C-422D-AA91-8FEE88E7A54D}"/>
+                <a16:creationId xmlns:a16="http://schemas.microsoft.com/office/drawing/2014/main" id="{390BA3C7-AA75-49B8-AA48-21F3527FC9A4}"/>
               </a:ext>
             </a:extLst>
           </p:cNvPr>
@@ -9836,7 +9836,7 @@
           <p:cNvPr id="14" name="">
             <a:extLst xmlns:a="http://schemas.openxmlformats.org/drawingml/2006/main">
               <a:ext uri="{FF2B5EF4-FFF2-40B4-BE49-F238E27FC236}">
-                <a16:creationId xmlns:a16="http://schemas.microsoft.com/office/drawing/2014/main" id="{993389CB-28A8-4DBC-A245-A3D242F9FD6C}"/>
+                <a16:creationId xmlns:a16="http://schemas.microsoft.com/office/drawing/2014/main" id="{95C26D6E-745B-4751-9738-83398087F5E4}"/>
               </a:ext>
             </a:extLst>
           </p:cNvPr>
@@ -9866,7 +9866,7 @@
           <p:cNvPr id="15" name="">
             <a:extLst xmlns:a="http://schemas.openxmlformats.org/drawingml/2006/main">
               <a:ext uri="{FF2B5EF4-FFF2-40B4-BE49-F238E27FC236}">
-                <a16:creationId xmlns:a16="http://schemas.microsoft.com/office/drawing/2014/main" id="{93C9DE7D-8FFA-4213-BAC2-DC6A250F0287}"/>
+                <a16:creationId xmlns:a16="http://schemas.microsoft.com/office/drawing/2014/main" id="{E9FA95E1-8462-4AAC-8020-4A7BB8EEBCDC}"/>
               </a:ext>
             </a:extLst>
           </p:cNvPr>
@@ -9974,7 +9974,7 @@
           <p:cNvPr id="16" name="">
             <a:extLst xmlns:a="http://schemas.openxmlformats.org/drawingml/2006/main">
               <a:ext uri="{FF2B5EF4-FFF2-40B4-BE49-F238E27FC236}">
-                <a16:creationId xmlns:a16="http://schemas.microsoft.com/office/drawing/2014/main" id="{87631336-275F-45A3-A264-BA9A32894B09}"/>
+                <a16:creationId xmlns:a16="http://schemas.microsoft.com/office/drawing/2014/main" id="{3159A635-442B-4133-B3FC-A0246AF0CDD4}"/>
               </a:ext>
             </a:extLst>
           </p:cNvPr>
@@ -10029,7 +10029,7 @@
     </p:spTree>
     <p:extLst>
       <p:ext uri="{BB962C8B-B14F-4D97-AF65-F5344CB8AC3E}">
-        <p14:creationId xmlns:p14="http://schemas.microsoft.com/office/powerpoint/2010/main" val="840673127"/>
+        <p14:creationId xmlns:p14="http://schemas.microsoft.com/office/powerpoint/2010/main" val="1851239232"/>
       </p:ext>
     </p:extLst>
   </p:cSld>
@@ -10060,7 +10060,7 @@
           <p:cNvPr id="3" name="Freeform 3">
             <a:extLst xmlns:a="http://schemas.openxmlformats.org/drawingml/2006/main">
               <a:ext uri="{FF2B5EF4-FFF2-40B4-BE49-F238E27FC236}">
-                <a16:creationId xmlns:a16="http://schemas.microsoft.com/office/drawing/2014/main" id="{5E213938-9412-4C60-AB66-E95B45266183}"/>
+                <a16:creationId xmlns:a16="http://schemas.microsoft.com/office/drawing/2014/main" id="{3B9DD02C-9ECB-429C-9019-EDB20BB996AB}"/>
               </a:ext>
             </a:extLst>
           </p:cNvPr>
@@ -10123,7 +10123,7 @@
           <p:cNvPr id="4" name="TextBox 4">
             <a:extLst xmlns:a="http://schemas.openxmlformats.org/drawingml/2006/main">
               <a:ext uri="{FF2B5EF4-FFF2-40B4-BE49-F238E27FC236}">
-                <a16:creationId xmlns:a16="http://schemas.microsoft.com/office/drawing/2014/main" id="{45DDD880-F264-419D-A790-4A541F0A0EC3}"/>
+                <a16:creationId xmlns:a16="http://schemas.microsoft.com/office/drawing/2014/main" id="{13AFFEC2-7972-4A1E-893C-18F2673A914D}"/>
               </a:ext>
             </a:extLst>
           </p:cNvPr>
@@ -10160,7 +10160,7 @@
           <p:cNvPr id="5" name="TextBox 5">
             <a:extLst xmlns:a="http://schemas.openxmlformats.org/drawingml/2006/main">
               <a:ext uri="{FF2B5EF4-FFF2-40B4-BE49-F238E27FC236}">
-                <a16:creationId xmlns:a16="http://schemas.microsoft.com/office/drawing/2014/main" id="{53A3B428-49A1-4923-A17D-507C4A65FD2F}"/>
+                <a16:creationId xmlns:a16="http://schemas.microsoft.com/office/drawing/2014/main" id="{3533BAF5-8873-4825-8E35-85BF98A39419}"/>
               </a:ext>
             </a:extLst>
           </p:cNvPr>
@@ -10212,7 +10212,7 @@
           <p:cNvPr id="6" name="TextBox 6">
             <a:extLst xmlns:a="http://schemas.openxmlformats.org/drawingml/2006/main">
               <a:ext uri="{FF2B5EF4-FFF2-40B4-BE49-F238E27FC236}">
-                <a16:creationId xmlns:a16="http://schemas.microsoft.com/office/drawing/2014/main" id="{18DF83C3-3B77-44DB-B573-24225B23A6AC}"/>
+                <a16:creationId xmlns:a16="http://schemas.microsoft.com/office/drawing/2014/main" id="{DCFE84E5-3BEA-4351-97F4-CDE319EAA304}"/>
               </a:ext>
             </a:extLst>
           </p:cNvPr>
@@ -10262,7 +10262,7 @@
           <p:cNvPr id="7" name="Freeform 7">
             <a:extLst xmlns:a="http://schemas.openxmlformats.org/drawingml/2006/main">
               <a:ext uri="{FF2B5EF4-FFF2-40B4-BE49-F238E27FC236}">
-                <a16:creationId xmlns:a16="http://schemas.microsoft.com/office/drawing/2014/main" id="{6B0A53CC-F958-4839-A5AE-1FC177DF15C2}"/>
+                <a16:creationId xmlns:a16="http://schemas.microsoft.com/office/drawing/2014/main" id="{E5D5B10D-2DF0-4861-8336-DF0D91257074}"/>
               </a:ext>
             </a:extLst>
           </p:cNvPr>
@@ -10300,10 +10300,10 @@
             </a:pathLst>
           </a:custGeom>
           <a:blipFill xmlns:a="http://schemas.openxmlformats.org/drawingml/2006/main">
-            <a:blip xmlns:r="http://schemas.openxmlformats.org/officeDocument/2006/relationships" r:embed="R0d28e3e0e4c1493e">
+            <a:blip xmlns:r="http://schemas.openxmlformats.org/officeDocument/2006/relationships" r:embed="R5e9a89c7a1f64b8a">
               <a:extLst>
                 <a:ext uri="{96DAC541-7B7A-43D3-8B79-37D633B846F1}">
-                  <asvg:svgBlip xmlns:asvg="http://schemas.microsoft.com/office/drawing/2016/SVG/main" r:embed="Rb6697ee5d0594dd0"/>
+                  <asvg:svgBlip xmlns:asvg="http://schemas.microsoft.com/office/drawing/2016/SVG/main" r:embed="R6f324912753446c7"/>
                 </a:ext>
               </a:extLst>
             </a:blip>
@@ -10325,7 +10325,7 @@
           <p:cNvPr id="8" name="">
             <a:extLst xmlns:a="http://schemas.openxmlformats.org/drawingml/2006/main">
               <a:ext uri="{FF2B5EF4-FFF2-40B4-BE49-F238E27FC236}">
-                <a16:creationId xmlns:a16="http://schemas.microsoft.com/office/drawing/2014/main" id="{218AC2C6-69E1-4C0F-BF80-F193CB67CBC8}"/>
+                <a16:creationId xmlns:a16="http://schemas.microsoft.com/office/drawing/2014/main" id="{0FC92D3D-6EAD-431B-8513-CC4402B2FEA2}"/>
               </a:ext>
             </a:extLst>
           </p:cNvPr>
@@ -10382,7 +10382,7 @@
           <p:cNvPr id="9" name="">
             <a:extLst xmlns:a="http://schemas.openxmlformats.org/drawingml/2006/main">
               <a:ext uri="{FF2B5EF4-FFF2-40B4-BE49-F238E27FC236}">
-                <a16:creationId xmlns:a16="http://schemas.microsoft.com/office/drawing/2014/main" id="{8E0CB278-14BF-4E8A-BD8E-A70CCF8C2AAB}"/>
+                <a16:creationId xmlns:a16="http://schemas.microsoft.com/office/drawing/2014/main" id="{D2399820-C888-447B-A94B-EC1852825759}"/>
               </a:ext>
             </a:extLst>
           </p:cNvPr>
@@ -10439,7 +10439,7 @@
           <p:cNvPr id="10" name="">
             <a:extLst xmlns:a="http://schemas.openxmlformats.org/drawingml/2006/main">
               <a:ext uri="{FF2B5EF4-FFF2-40B4-BE49-F238E27FC236}">
-                <a16:creationId xmlns:a16="http://schemas.microsoft.com/office/drawing/2014/main" id="{CBE869CD-32D0-4BEB-ACAF-2E66C8F30753}"/>
+                <a16:creationId xmlns:a16="http://schemas.microsoft.com/office/drawing/2014/main" id="{071C7D7E-59AC-4596-88CC-48A098207D5B}"/>
               </a:ext>
             </a:extLst>
           </p:cNvPr>
@@ -10496,7 +10496,7 @@
           <p:cNvPr id="11" name="">
             <a:extLst xmlns:a="http://schemas.openxmlformats.org/drawingml/2006/main">
               <a:ext uri="{FF2B5EF4-FFF2-40B4-BE49-F238E27FC236}">
-                <a16:creationId xmlns:a16="http://schemas.microsoft.com/office/drawing/2014/main" id="{9B2C72A0-3173-457F-B10F-2415D3BA010B}"/>
+                <a16:creationId xmlns:a16="http://schemas.microsoft.com/office/drawing/2014/main" id="{2B72334B-75BF-47D8-837B-6B5A79641727}"/>
               </a:ext>
             </a:extLst>
           </p:cNvPr>
@@ -10553,7 +10553,7 @@
           <p:cNvPr id="12" name="">
             <a:extLst xmlns:a="http://schemas.openxmlformats.org/drawingml/2006/main">
               <a:ext uri="{FF2B5EF4-FFF2-40B4-BE49-F238E27FC236}">
-                <a16:creationId xmlns:a16="http://schemas.microsoft.com/office/drawing/2014/main" id="{A47D629A-7B9E-44EC-8E7A-141BC1B9A5DE}"/>
+                <a16:creationId xmlns:a16="http://schemas.microsoft.com/office/drawing/2014/main" id="{64898FD9-3CB2-4587-B7D2-EA6236EE47BF}"/>
               </a:ext>
             </a:extLst>
           </p:cNvPr>
@@ -10610,7 +10610,7 @@
           <p:cNvPr id="13" name="">
             <a:extLst xmlns:a="http://schemas.openxmlformats.org/drawingml/2006/main">
               <a:ext uri="{FF2B5EF4-FFF2-40B4-BE49-F238E27FC236}">
-                <a16:creationId xmlns:a16="http://schemas.microsoft.com/office/drawing/2014/main" id="{982C7556-6271-4111-A5BA-CEA2252B1198}"/>
+                <a16:creationId xmlns:a16="http://schemas.microsoft.com/office/drawing/2014/main" id="{6FD42E87-81E6-498A-9887-55DC5E67AC8E}"/>
               </a:ext>
             </a:extLst>
           </p:cNvPr>
@@ -10667,7 +10667,7 @@
           <p:cNvPr id="14" name="">
             <a:extLst xmlns:a="http://schemas.openxmlformats.org/drawingml/2006/main">
               <a:ext uri="{FF2B5EF4-FFF2-40B4-BE49-F238E27FC236}">
-                <a16:creationId xmlns:a16="http://schemas.microsoft.com/office/drawing/2014/main" id="{6CEA8E12-5621-46FA-8FFD-F51D2255E587}"/>
+                <a16:creationId xmlns:a16="http://schemas.microsoft.com/office/drawing/2014/main" id="{34CA904B-A712-49C1-B964-E2A32932240B}"/>
               </a:ext>
             </a:extLst>
           </p:cNvPr>
@@ -10724,7 +10724,7 @@
           <p:cNvPr id="15" name="">
             <a:extLst xmlns:a="http://schemas.openxmlformats.org/drawingml/2006/main">
               <a:ext uri="{FF2B5EF4-FFF2-40B4-BE49-F238E27FC236}">
-                <a16:creationId xmlns:a16="http://schemas.microsoft.com/office/drawing/2014/main" id="{4F363BF7-60CD-4AE4-AF90-01C468BA765F}"/>
+                <a16:creationId xmlns:a16="http://schemas.microsoft.com/office/drawing/2014/main" id="{7CDF1980-EED6-4268-AED6-5E0549EED163}"/>
               </a:ext>
             </a:extLst>
           </p:cNvPr>
@@ -10781,7 +10781,7 @@
           <p:cNvPr id="16" name="">
             <a:extLst xmlns:a="http://schemas.openxmlformats.org/drawingml/2006/main">
               <a:ext uri="{FF2B5EF4-FFF2-40B4-BE49-F238E27FC236}">
-                <a16:creationId xmlns:a16="http://schemas.microsoft.com/office/drawing/2014/main" id="{0D129FB0-0415-4301-BEC9-39EC5ADCA9E9}"/>
+                <a16:creationId xmlns:a16="http://schemas.microsoft.com/office/drawing/2014/main" id="{9424E51E-A81F-4E47-B6E5-8C22A3951BD3}"/>
               </a:ext>
             </a:extLst>
           </p:cNvPr>
@@ -10838,7 +10838,7 @@
           <p:cNvPr id="17" name="">
             <a:extLst xmlns:a="http://schemas.openxmlformats.org/drawingml/2006/main">
               <a:ext uri="{FF2B5EF4-FFF2-40B4-BE49-F238E27FC236}">
-                <a16:creationId xmlns:a16="http://schemas.microsoft.com/office/drawing/2014/main" id="{F6DF15CE-661E-41F3-8E29-4A3F4A4973DB}"/>
+                <a16:creationId xmlns:a16="http://schemas.microsoft.com/office/drawing/2014/main" id="{9181ADEF-8D60-49DA-878C-3AD89DEE24EC}"/>
               </a:ext>
             </a:extLst>
           </p:cNvPr>
@@ -10893,7 +10893,7 @@
     </p:spTree>
     <p:extLst>
       <p:ext uri="{BB962C8B-B14F-4D97-AF65-F5344CB8AC3E}">
-        <p14:creationId xmlns:p14="http://schemas.microsoft.com/office/powerpoint/2010/main" val="1708461908"/>
+        <p14:creationId xmlns:p14="http://schemas.microsoft.com/office/powerpoint/2010/main" val="1637129844"/>
       </p:ext>
     </p:extLst>
   </p:cSld>
@@ -10924,7 +10924,7 @@
           <p:cNvPr id="3" name="Freeform 3">
             <a:extLst xmlns:a="http://schemas.openxmlformats.org/drawingml/2006/main">
               <a:ext uri="{FF2B5EF4-FFF2-40B4-BE49-F238E27FC236}">
-                <a16:creationId xmlns:a16="http://schemas.microsoft.com/office/drawing/2014/main" id="{3553B9C5-52E1-4CF6-A3E3-66D9CB58CE38}"/>
+                <a16:creationId xmlns:a16="http://schemas.microsoft.com/office/drawing/2014/main" id="{D87E1DEF-AFF8-43C9-86BB-3AED7AE511FD}"/>
               </a:ext>
             </a:extLst>
           </p:cNvPr>
@@ -10987,7 +10987,7 @@
           <p:cNvPr id="4" name="TextBox 4">
             <a:extLst xmlns:a="http://schemas.openxmlformats.org/drawingml/2006/main">
               <a:ext uri="{FF2B5EF4-FFF2-40B4-BE49-F238E27FC236}">
-                <a16:creationId xmlns:a16="http://schemas.microsoft.com/office/drawing/2014/main" id="{CEE714B2-F87B-4BBB-BF6C-2111A8E92B07}"/>
+                <a16:creationId xmlns:a16="http://schemas.microsoft.com/office/drawing/2014/main" id="{7BC5C66D-4EF3-47D0-9207-1DB7BBDCD7CD}"/>
               </a:ext>
             </a:extLst>
           </p:cNvPr>
@@ -11024,7 +11024,7 @@
           <p:cNvPr id="5" name="TextBox 5">
             <a:extLst xmlns:a="http://schemas.openxmlformats.org/drawingml/2006/main">
               <a:ext uri="{FF2B5EF4-FFF2-40B4-BE49-F238E27FC236}">
-                <a16:creationId xmlns:a16="http://schemas.microsoft.com/office/drawing/2014/main" id="{F197AD4C-D4FE-4BBF-A5CB-90E6E558A946}"/>
+                <a16:creationId xmlns:a16="http://schemas.microsoft.com/office/drawing/2014/main" id="{98CC2C27-B7ED-4C27-A346-97A8438C3B7E}"/>
               </a:ext>
             </a:extLst>
           </p:cNvPr>
@@ -11076,7 +11076,7 @@
           <p:cNvPr id="6" name="TextBox 6">
             <a:extLst xmlns:a="http://schemas.openxmlformats.org/drawingml/2006/main">
               <a:ext uri="{FF2B5EF4-FFF2-40B4-BE49-F238E27FC236}">
-                <a16:creationId xmlns:a16="http://schemas.microsoft.com/office/drawing/2014/main" id="{1BF98ED5-52F3-4491-9EE1-6F63BB6C8AB8}"/>
+                <a16:creationId xmlns:a16="http://schemas.microsoft.com/office/drawing/2014/main" id="{1593BDB9-6CA6-46AA-8531-3AFDB66E051D}"/>
               </a:ext>
             </a:extLst>
           </p:cNvPr>
@@ -11126,7 +11126,7 @@
           <p:cNvPr id="7" name="Freeform 7">
             <a:extLst xmlns:a="http://schemas.openxmlformats.org/drawingml/2006/main">
               <a:ext uri="{FF2B5EF4-FFF2-40B4-BE49-F238E27FC236}">
-                <a16:creationId xmlns:a16="http://schemas.microsoft.com/office/drawing/2014/main" id="{3257FD78-16B4-4C3D-8977-5EDB0407942E}"/>
+                <a16:creationId xmlns:a16="http://schemas.microsoft.com/office/drawing/2014/main" id="{9FAB8608-9DC3-4768-BCB4-C476F8BCAD91}"/>
               </a:ext>
             </a:extLst>
           </p:cNvPr>
@@ -11164,10 +11164,10 @@
             </a:pathLst>
           </a:custGeom>
           <a:blipFill xmlns:a="http://schemas.openxmlformats.org/drawingml/2006/main">
-            <a:blip xmlns:r="http://schemas.openxmlformats.org/officeDocument/2006/relationships" r:embed="Rb44a51befc9e4f62">
+            <a:blip xmlns:r="http://schemas.openxmlformats.org/officeDocument/2006/relationships" r:embed="Rfecd435360d44f22">
               <a:extLst>
                 <a:ext uri="{96DAC541-7B7A-43D3-8B79-37D633B846F1}">
-                  <asvg:svgBlip xmlns:asvg="http://schemas.microsoft.com/office/drawing/2016/SVG/main" r:embed="R2f7dd822f93b4c31"/>
+                  <asvg:svgBlip xmlns:asvg="http://schemas.microsoft.com/office/drawing/2016/SVG/main" r:embed="R5ccde8a4ce07431e"/>
                 </a:ext>
               </a:extLst>
             </a:blip>
@@ -11189,7 +11189,7 @@
           <p:cNvPr id="8" name="">
             <a:extLst xmlns:a="http://schemas.openxmlformats.org/drawingml/2006/main">
               <a:ext uri="{FF2B5EF4-FFF2-40B4-BE49-F238E27FC236}">
-                <a16:creationId xmlns:a16="http://schemas.microsoft.com/office/drawing/2014/main" id="{9F69FFD1-B58F-414E-8516-3DEBF573B6E8}"/>
+                <a16:creationId xmlns:a16="http://schemas.microsoft.com/office/drawing/2014/main" id="{C834E076-A411-4481-A10A-46BA8402FA88}"/>
               </a:ext>
             </a:extLst>
           </p:cNvPr>
@@ -11221,7 +11221,7 @@
           <p:cNvPr id="9" name="">
             <a:extLst xmlns:a="http://schemas.openxmlformats.org/drawingml/2006/main">
               <a:ext uri="{FF2B5EF4-FFF2-40B4-BE49-F238E27FC236}">
-                <a16:creationId xmlns:a16="http://schemas.microsoft.com/office/drawing/2014/main" id="{533B9C27-C6B0-45FC-93A0-E340F7BBCF73}"/>
+                <a16:creationId xmlns:a16="http://schemas.microsoft.com/office/drawing/2014/main" id="{9C496461-D237-40BE-A0F5-D99095D3EFEC}"/>
               </a:ext>
             </a:extLst>
           </p:cNvPr>
@@ -11251,7 +11251,7 @@
           <p:cNvPr id="10" name="">
             <a:extLst xmlns:a="http://schemas.openxmlformats.org/drawingml/2006/main">
               <a:ext uri="{FF2B5EF4-FFF2-40B4-BE49-F238E27FC236}">
-                <a16:creationId xmlns:a16="http://schemas.microsoft.com/office/drawing/2014/main" id="{82141005-5BC5-4AC2-8B4E-0D790E62E812}"/>
+                <a16:creationId xmlns:a16="http://schemas.microsoft.com/office/drawing/2014/main" id="{DB0B8C38-A555-49B4-9D68-ADA6F2D16AA7}"/>
               </a:ext>
             </a:extLst>
           </p:cNvPr>
@@ -11336,7 +11336,7 @@
           <p:cNvPr id="11" name="">
             <a:extLst xmlns:a="http://schemas.openxmlformats.org/drawingml/2006/main">
               <a:ext uri="{FF2B5EF4-FFF2-40B4-BE49-F238E27FC236}">
-                <a16:creationId xmlns:a16="http://schemas.microsoft.com/office/drawing/2014/main" id="{0415C849-6AA6-464A-9545-01F04EEA1067}"/>
+                <a16:creationId xmlns:a16="http://schemas.microsoft.com/office/drawing/2014/main" id="{7302AF03-39BF-4FE8-9310-6870F2F6893A}"/>
               </a:ext>
             </a:extLst>
           </p:cNvPr>
@@ -11368,7 +11368,7 @@
           <p:cNvPr id="12" name="">
             <a:extLst xmlns:a="http://schemas.openxmlformats.org/drawingml/2006/main">
               <a:ext uri="{FF2B5EF4-FFF2-40B4-BE49-F238E27FC236}">
-                <a16:creationId xmlns:a16="http://schemas.microsoft.com/office/drawing/2014/main" id="{34762EAE-6E00-4097-AC74-84ABCA8C0C6C}"/>
+                <a16:creationId xmlns:a16="http://schemas.microsoft.com/office/drawing/2014/main" id="{631D82D7-22D1-40BB-89C2-7223DB67C4F1}"/>
               </a:ext>
             </a:extLst>
           </p:cNvPr>
@@ -11398,7 +11398,7 @@
           <p:cNvPr id="13" name="">
             <a:extLst xmlns:a="http://schemas.openxmlformats.org/drawingml/2006/main">
               <a:ext uri="{FF2B5EF4-FFF2-40B4-BE49-F238E27FC236}">
-                <a16:creationId xmlns:a16="http://schemas.microsoft.com/office/drawing/2014/main" id="{04536C34-68D0-4C52-B780-989D566E214C}"/>
+                <a16:creationId xmlns:a16="http://schemas.microsoft.com/office/drawing/2014/main" id="{2AA6BD70-5ED0-4599-83DC-27C87EE233F7}"/>
               </a:ext>
             </a:extLst>
           </p:cNvPr>
@@ -11483,7 +11483,7 @@
           <p:cNvPr id="14" name="">
             <a:extLst xmlns:a="http://schemas.openxmlformats.org/drawingml/2006/main">
               <a:ext uri="{FF2B5EF4-FFF2-40B4-BE49-F238E27FC236}">
-                <a16:creationId xmlns:a16="http://schemas.microsoft.com/office/drawing/2014/main" id="{70979A93-473E-4922-8BCB-491FB62175E9}"/>
+                <a16:creationId xmlns:a16="http://schemas.microsoft.com/office/drawing/2014/main" id="{473426AF-ED3C-4F37-828A-25698E6F17D1}"/>
               </a:ext>
             </a:extLst>
           </p:cNvPr>
@@ -11515,7 +11515,7 @@
           <p:cNvPr id="15" name="">
             <a:extLst xmlns:a="http://schemas.openxmlformats.org/drawingml/2006/main">
               <a:ext uri="{FF2B5EF4-FFF2-40B4-BE49-F238E27FC236}">
-                <a16:creationId xmlns:a16="http://schemas.microsoft.com/office/drawing/2014/main" id="{3830B5B1-B5F9-4F45-B918-5A5655DB7A2B}"/>
+                <a16:creationId xmlns:a16="http://schemas.microsoft.com/office/drawing/2014/main" id="{775D9C23-C6AD-4D8C-AA55-E6DCD7D6F23D}"/>
               </a:ext>
             </a:extLst>
           </p:cNvPr>
@@ -11545,7 +11545,7 @@
           <p:cNvPr id="16" name="">
             <a:extLst xmlns:a="http://schemas.openxmlformats.org/drawingml/2006/main">
               <a:ext uri="{FF2B5EF4-FFF2-40B4-BE49-F238E27FC236}">
-                <a16:creationId xmlns:a16="http://schemas.microsoft.com/office/drawing/2014/main" id="{079D4766-C1A3-490F-A831-6FAC2EB5BE97}"/>
+                <a16:creationId xmlns:a16="http://schemas.microsoft.com/office/drawing/2014/main" id="{91C006FA-64C2-4362-A28A-1C01D81E4D17}"/>
               </a:ext>
             </a:extLst>
           </p:cNvPr>
@@ -11630,7 +11630,7 @@
           <p:cNvPr id="17" name="">
             <a:extLst xmlns:a="http://schemas.openxmlformats.org/drawingml/2006/main">
               <a:ext uri="{FF2B5EF4-FFF2-40B4-BE49-F238E27FC236}">
-                <a16:creationId xmlns:a16="http://schemas.microsoft.com/office/drawing/2014/main" id="{75B5C532-80FA-4F43-AD21-A4F46BBFD5CE}"/>
+                <a16:creationId xmlns:a16="http://schemas.microsoft.com/office/drawing/2014/main" id="{972881C3-B4E1-4D4E-9725-80A970C26E04}"/>
               </a:ext>
             </a:extLst>
           </p:cNvPr>
@@ -11662,7 +11662,7 @@
           <p:cNvPr id="18" name="">
             <a:extLst xmlns:a="http://schemas.openxmlformats.org/drawingml/2006/main">
               <a:ext uri="{FF2B5EF4-FFF2-40B4-BE49-F238E27FC236}">
-                <a16:creationId xmlns:a16="http://schemas.microsoft.com/office/drawing/2014/main" id="{6B0D9E49-0B9C-4049-A645-A81E6D1CE0E0}"/>
+                <a16:creationId xmlns:a16="http://schemas.microsoft.com/office/drawing/2014/main" id="{FCED2C3E-52E1-4759-8C7B-439243126D2A}"/>
               </a:ext>
             </a:extLst>
           </p:cNvPr>
@@ -11692,7 +11692,7 @@
           <p:cNvPr id="19" name="">
             <a:extLst xmlns:a="http://schemas.openxmlformats.org/drawingml/2006/main">
               <a:ext uri="{FF2B5EF4-FFF2-40B4-BE49-F238E27FC236}">
-                <a16:creationId xmlns:a16="http://schemas.microsoft.com/office/drawing/2014/main" id="{8737E1B7-494A-4402-A58A-FCC16752F12D}"/>
+                <a16:creationId xmlns:a16="http://schemas.microsoft.com/office/drawing/2014/main" id="{79FA5A88-7504-409E-9F15-A5FAA91DE9BA}"/>
               </a:ext>
             </a:extLst>
           </p:cNvPr>
@@ -11777,7 +11777,7 @@
           <p:cNvPr id="20" name="">
             <a:extLst xmlns:a="http://schemas.openxmlformats.org/drawingml/2006/main">
               <a:ext uri="{FF2B5EF4-FFF2-40B4-BE49-F238E27FC236}">
-                <a16:creationId xmlns:a16="http://schemas.microsoft.com/office/drawing/2014/main" id="{A8FFDF4C-A2F8-46A9-9B46-08255DA5D0DB}"/>
+                <a16:creationId xmlns:a16="http://schemas.microsoft.com/office/drawing/2014/main" id="{17F27C7F-2265-4FCB-A0FA-94C583764276}"/>
               </a:ext>
             </a:extLst>
           </p:cNvPr>
@@ -11832,7 +11832,7 @@
     </p:spTree>
     <p:extLst>
       <p:ext uri="{BB962C8B-B14F-4D97-AF65-F5344CB8AC3E}">
-        <p14:creationId xmlns:p14="http://schemas.microsoft.com/office/powerpoint/2010/main" val="552267246"/>
+        <p14:creationId xmlns:p14="http://schemas.microsoft.com/office/powerpoint/2010/main" val="2037697516"/>
       </p:ext>
     </p:extLst>
   </p:cSld>
@@ -11863,7 +11863,7 @@
           <p:cNvPr id="3" name="Freeform 3">
             <a:extLst xmlns:a="http://schemas.openxmlformats.org/drawingml/2006/main">
               <a:ext uri="{FF2B5EF4-FFF2-40B4-BE49-F238E27FC236}">
-                <a16:creationId xmlns:a16="http://schemas.microsoft.com/office/drawing/2014/main" id="{4529B9FD-E765-4F3B-814D-AD65B6301920}"/>
+                <a16:creationId xmlns:a16="http://schemas.microsoft.com/office/drawing/2014/main" id="{B5C64BFD-1DF1-466A-9C7B-E08E673D52C0}"/>
               </a:ext>
             </a:extLst>
           </p:cNvPr>
@@ -11926,7 +11926,7 @@
           <p:cNvPr id="4" name="TextBox 4">
             <a:extLst xmlns:a="http://schemas.openxmlformats.org/drawingml/2006/main">
               <a:ext uri="{FF2B5EF4-FFF2-40B4-BE49-F238E27FC236}">
-                <a16:creationId xmlns:a16="http://schemas.microsoft.com/office/drawing/2014/main" id="{4A92940F-F9BD-4896-A85A-2C8A7E81AE98}"/>
+                <a16:creationId xmlns:a16="http://schemas.microsoft.com/office/drawing/2014/main" id="{61B4965B-C9BB-4351-9AAD-03BC544D0DDA}"/>
               </a:ext>
             </a:extLst>
           </p:cNvPr>
@@ -11963,7 +11963,7 @@
           <p:cNvPr id="5" name="TextBox 5">
             <a:extLst xmlns:a="http://schemas.openxmlformats.org/drawingml/2006/main">
               <a:ext uri="{FF2B5EF4-FFF2-40B4-BE49-F238E27FC236}">
-                <a16:creationId xmlns:a16="http://schemas.microsoft.com/office/drawing/2014/main" id="{F3505AB9-CF0E-4178-9476-25178A38696C}"/>
+                <a16:creationId xmlns:a16="http://schemas.microsoft.com/office/drawing/2014/main" id="{5E03F37A-4693-4821-BCDE-60468D589D65}"/>
               </a:ext>
             </a:extLst>
           </p:cNvPr>
@@ -12005,7 +12005,7 @@
           <p:cNvPr id="6" name="Freeform 6">
             <a:extLst xmlns:a="http://schemas.openxmlformats.org/drawingml/2006/main">
               <a:ext uri="{FF2B5EF4-FFF2-40B4-BE49-F238E27FC236}">
-                <a16:creationId xmlns:a16="http://schemas.microsoft.com/office/drawing/2014/main" id="{3F97214D-4DB1-4E59-ACB6-8894B7D675E2}"/>
+                <a16:creationId xmlns:a16="http://schemas.microsoft.com/office/drawing/2014/main" id="{F090C49D-BB1F-45F3-B479-3D58BFF30CD8}"/>
               </a:ext>
             </a:extLst>
           </p:cNvPr>
@@ -12043,10 +12043,10 @@
             </a:pathLst>
           </a:custGeom>
           <a:blipFill xmlns:a="http://schemas.openxmlformats.org/drawingml/2006/main">
-            <a:blip xmlns:r="http://schemas.openxmlformats.org/officeDocument/2006/relationships" r:embed="R7f9e2f660fb340dc">
+            <a:blip xmlns:r="http://schemas.openxmlformats.org/officeDocument/2006/relationships" r:embed="R03476b3516f54f71">
               <a:extLst>
                 <a:ext uri="{96DAC541-7B7A-43D3-8B79-37D633B846F1}">
-                  <asvg:svgBlip xmlns:asvg="http://schemas.microsoft.com/office/drawing/2016/SVG/main" r:embed="R09b9c5adefad462b"/>
+                  <asvg:svgBlip xmlns:asvg="http://schemas.microsoft.com/office/drawing/2016/SVG/main" r:embed="R723a3c14eb374ec4"/>
                 </a:ext>
               </a:extLst>
             </a:blip>
@@ -12068,7 +12068,7 @@
           <p:cNvPr id="7" name="TextBox 7">
             <a:extLst xmlns:a="http://schemas.openxmlformats.org/drawingml/2006/main">
               <a:ext uri="{FF2B5EF4-FFF2-40B4-BE49-F238E27FC236}">
-                <a16:creationId xmlns:a16="http://schemas.microsoft.com/office/drawing/2014/main" id="{5BB809EF-1953-43C4-9D68-49BA15664170}"/>
+                <a16:creationId xmlns:a16="http://schemas.microsoft.com/office/drawing/2014/main" id="{FFBFC79A-7CB7-4A47-9C8E-1990B06A5764}"/>
               </a:ext>
             </a:extLst>
           </p:cNvPr>
@@ -12120,7 +12120,7 @@
           <p:cNvPr id="8" name="">
             <a:extLst xmlns:a="http://schemas.openxmlformats.org/drawingml/2006/main">
               <a:ext uri="{FF2B5EF4-FFF2-40B4-BE49-F238E27FC236}">
-                <a16:creationId xmlns:a16="http://schemas.microsoft.com/office/drawing/2014/main" id="{868AFFBE-84A5-45C0-89DD-5A4A6F319236}"/>
+                <a16:creationId xmlns:a16="http://schemas.microsoft.com/office/drawing/2014/main" id="{8C5C11E8-5562-473B-A509-C6F74F7F632F}"/>
               </a:ext>
             </a:extLst>
           </p:cNvPr>
@@ -12177,7 +12177,7 @@
           <p:cNvPr id="9" name="">
             <a:extLst xmlns:a="http://schemas.openxmlformats.org/drawingml/2006/main">
               <a:ext uri="{FF2B5EF4-FFF2-40B4-BE49-F238E27FC236}">
-                <a16:creationId xmlns:a16="http://schemas.microsoft.com/office/drawing/2014/main" id="{B596AF90-7D71-410E-B894-1C931CA7F9A2}"/>
+                <a16:creationId xmlns:a16="http://schemas.microsoft.com/office/drawing/2014/main" id="{9DAAD408-C9B2-4361-9A3F-0948E149F310}"/>
               </a:ext>
             </a:extLst>
           </p:cNvPr>
@@ -12234,7 +12234,7 @@
           <p:cNvPr id="10" name="">
             <a:extLst xmlns:a="http://schemas.openxmlformats.org/drawingml/2006/main">
               <a:ext uri="{FF2B5EF4-FFF2-40B4-BE49-F238E27FC236}">
-                <a16:creationId xmlns:a16="http://schemas.microsoft.com/office/drawing/2014/main" id="{F98E1EF9-49D2-45E3-8A40-E7F3DB6367CE}"/>
+                <a16:creationId xmlns:a16="http://schemas.microsoft.com/office/drawing/2014/main" id="{47FF3C66-A71C-499D-93E3-7B528DB23D4D}"/>
               </a:ext>
             </a:extLst>
           </p:cNvPr>
@@ -12291,7 +12291,7 @@
           <p:cNvPr id="11" name="">
             <a:extLst xmlns:a="http://schemas.openxmlformats.org/drawingml/2006/main">
               <a:ext uri="{FF2B5EF4-FFF2-40B4-BE49-F238E27FC236}">
-                <a16:creationId xmlns:a16="http://schemas.microsoft.com/office/drawing/2014/main" id="{55D8C6AD-68F0-476C-9046-AAABF2CF9A2A}"/>
+                <a16:creationId xmlns:a16="http://schemas.microsoft.com/office/drawing/2014/main" id="{172A3FF4-F0C2-4A0E-8DCE-EACB21AEED95}"/>
               </a:ext>
             </a:extLst>
           </p:cNvPr>
@@ -12348,7 +12348,7 @@
           <p:cNvPr id="12" name="">
             <a:extLst xmlns:a="http://schemas.openxmlformats.org/drawingml/2006/main">
               <a:ext uri="{FF2B5EF4-FFF2-40B4-BE49-F238E27FC236}">
-                <a16:creationId xmlns:a16="http://schemas.microsoft.com/office/drawing/2014/main" id="{D7DE7399-B7BF-47D4-8149-6589A14E7C6F}"/>
+                <a16:creationId xmlns:a16="http://schemas.microsoft.com/office/drawing/2014/main" id="{9AF54B1B-0337-46AF-9646-838BFCAF3E3D}"/>
               </a:ext>
             </a:extLst>
           </p:cNvPr>
@@ -12405,7 +12405,7 @@
           <p:cNvPr id="13" name="">
             <a:extLst xmlns:a="http://schemas.openxmlformats.org/drawingml/2006/main">
               <a:ext uri="{FF2B5EF4-FFF2-40B4-BE49-F238E27FC236}">
-                <a16:creationId xmlns:a16="http://schemas.microsoft.com/office/drawing/2014/main" id="{EA934F7E-C40F-4BF2-80D6-433E77F8E93F}"/>
+                <a16:creationId xmlns:a16="http://schemas.microsoft.com/office/drawing/2014/main" id="{1F7CC110-F9BF-46D6-9798-C21DE314DF4D}"/>
               </a:ext>
             </a:extLst>
           </p:cNvPr>
@@ -12462,7 +12462,7 @@
           <p:cNvPr id="14" name="">
             <a:extLst xmlns:a="http://schemas.openxmlformats.org/drawingml/2006/main">
               <a:ext uri="{FF2B5EF4-FFF2-40B4-BE49-F238E27FC236}">
-                <a16:creationId xmlns:a16="http://schemas.microsoft.com/office/drawing/2014/main" id="{35E895CC-17EA-4616-B6B9-7D95F5B75A09}"/>
+                <a16:creationId xmlns:a16="http://schemas.microsoft.com/office/drawing/2014/main" id="{A31574CD-CD0B-4D24-A6C8-4D8A5A050D2B}"/>
               </a:ext>
             </a:extLst>
           </p:cNvPr>
@@ -12492,7 +12492,7 @@
           <p:cNvPr id="15" name="">
             <a:extLst xmlns:a="http://schemas.openxmlformats.org/drawingml/2006/main">
               <a:ext uri="{FF2B5EF4-FFF2-40B4-BE49-F238E27FC236}">
-                <a16:creationId xmlns:a16="http://schemas.microsoft.com/office/drawing/2014/main" id="{2180751C-17B2-4865-A51B-E60F0890A2AE}"/>
+                <a16:creationId xmlns:a16="http://schemas.microsoft.com/office/drawing/2014/main" id="{8FB7A725-545B-484D-BA98-3F74426EBA8C}"/>
               </a:ext>
             </a:extLst>
           </p:cNvPr>
@@ -12549,7 +12549,7 @@
           <p:cNvPr id="16" name="">
             <a:extLst xmlns:a="http://schemas.openxmlformats.org/drawingml/2006/main">
               <a:ext uri="{FF2B5EF4-FFF2-40B4-BE49-F238E27FC236}">
-                <a16:creationId xmlns:a16="http://schemas.microsoft.com/office/drawing/2014/main" id="{CE87D268-77BF-41F8-B34C-9D6D7E455D65}"/>
+                <a16:creationId xmlns:a16="http://schemas.microsoft.com/office/drawing/2014/main" id="{F002CC8E-4A24-4191-AD04-AD0DE19480BC}"/>
               </a:ext>
             </a:extLst>
           </p:cNvPr>
@@ -12579,7 +12579,7 @@
           <p:cNvPr id="17" name="">
             <a:extLst xmlns:a="http://schemas.openxmlformats.org/drawingml/2006/main">
               <a:ext uri="{FF2B5EF4-FFF2-40B4-BE49-F238E27FC236}">
-                <a16:creationId xmlns:a16="http://schemas.microsoft.com/office/drawing/2014/main" id="{227189DA-EA2C-4904-B90A-1CD9F487B2F9}"/>
+                <a16:creationId xmlns:a16="http://schemas.microsoft.com/office/drawing/2014/main" id="{2FB72B20-C98D-4518-8C73-EF20D8B30D55}"/>
               </a:ext>
             </a:extLst>
           </p:cNvPr>
@@ -12634,7 +12634,7 @@
     </p:spTree>
     <p:extLst>
       <p:ext uri="{BB962C8B-B14F-4D97-AF65-F5344CB8AC3E}">
-        <p14:creationId xmlns:p14="http://schemas.microsoft.com/office/powerpoint/2010/main" val="826001639"/>
+        <p14:creationId xmlns:p14="http://schemas.microsoft.com/office/powerpoint/2010/main" val="336538649"/>
       </p:ext>
     </p:extLst>
   </p:cSld>
@@ -12665,7 +12665,7 @@
           <p:cNvPr id="3" name="Freeform 3">
             <a:extLst xmlns:a="http://schemas.openxmlformats.org/drawingml/2006/main">
               <a:ext uri="{FF2B5EF4-FFF2-40B4-BE49-F238E27FC236}">
-                <a16:creationId xmlns:a16="http://schemas.microsoft.com/office/drawing/2014/main" id="{EDA7F19D-227A-47BB-81BF-42D86A50631A}"/>
+                <a16:creationId xmlns:a16="http://schemas.microsoft.com/office/drawing/2014/main" id="{7067C93F-55B0-4B4C-86D8-2C632875E332}"/>
               </a:ext>
             </a:extLst>
           </p:cNvPr>
@@ -12728,7 +12728,7 @@
           <p:cNvPr id="4" name="TextBox 4">
             <a:extLst xmlns:a="http://schemas.openxmlformats.org/drawingml/2006/main">
               <a:ext uri="{FF2B5EF4-FFF2-40B4-BE49-F238E27FC236}">
-                <a16:creationId xmlns:a16="http://schemas.microsoft.com/office/drawing/2014/main" id="{AA4B0AD1-5035-4A07-A562-81483A2B80A3}"/>
+                <a16:creationId xmlns:a16="http://schemas.microsoft.com/office/drawing/2014/main" id="{7737D5FE-035A-48A5-B9E2-8F3E234C11BB}"/>
               </a:ext>
             </a:extLst>
           </p:cNvPr>
@@ -12765,7 +12765,7 @@
           <p:cNvPr id="5" name="TextBox 5">
             <a:extLst xmlns:a="http://schemas.openxmlformats.org/drawingml/2006/main">
               <a:ext uri="{FF2B5EF4-FFF2-40B4-BE49-F238E27FC236}">
-                <a16:creationId xmlns:a16="http://schemas.microsoft.com/office/drawing/2014/main" id="{35C6BD08-FCA7-4EF1-B899-D54FF0E33887}"/>
+                <a16:creationId xmlns:a16="http://schemas.microsoft.com/office/drawing/2014/main" id="{55DDC029-5C99-4BED-B2F4-DD4E30C11EE5}"/>
               </a:ext>
             </a:extLst>
           </p:cNvPr>
@@ -12807,7 +12807,7 @@
           <p:cNvPr id="6" name="Freeform 6">
             <a:extLst xmlns:a="http://schemas.openxmlformats.org/drawingml/2006/main">
               <a:ext uri="{FF2B5EF4-FFF2-40B4-BE49-F238E27FC236}">
-                <a16:creationId xmlns:a16="http://schemas.microsoft.com/office/drawing/2014/main" id="{EC261214-9A1B-4EC8-B121-0D0FCE075CB4}"/>
+                <a16:creationId xmlns:a16="http://schemas.microsoft.com/office/drawing/2014/main" id="{DE1E5C56-90B6-4867-A8E4-36451D94EDF9}"/>
               </a:ext>
             </a:extLst>
           </p:cNvPr>
@@ -12845,10 +12845,10 @@
             </a:pathLst>
           </a:custGeom>
           <a:blipFill xmlns:a="http://schemas.openxmlformats.org/drawingml/2006/main">
-            <a:blip xmlns:r="http://schemas.openxmlformats.org/officeDocument/2006/relationships" r:embed="R62a1a6ace09e441b">
+            <a:blip xmlns:r="http://schemas.openxmlformats.org/officeDocument/2006/relationships" r:embed="Rf55104e0a1564eff">
               <a:extLst>
                 <a:ext uri="{96DAC541-7B7A-43D3-8B79-37D633B846F1}">
-                  <asvg:svgBlip xmlns:asvg="http://schemas.microsoft.com/office/drawing/2016/SVG/main" r:embed="Rbd29a6828ece4303"/>
+                  <asvg:svgBlip xmlns:asvg="http://schemas.microsoft.com/office/drawing/2016/SVG/main" r:embed="R1b2ac89d022148ec"/>
                 </a:ext>
               </a:extLst>
             </a:blip>
@@ -12870,7 +12870,7 @@
           <p:cNvPr id="7" name="TextBox 7">
             <a:extLst xmlns:a="http://schemas.openxmlformats.org/drawingml/2006/main">
               <a:ext uri="{FF2B5EF4-FFF2-40B4-BE49-F238E27FC236}">
-                <a16:creationId xmlns:a16="http://schemas.microsoft.com/office/drawing/2014/main" id="{791E726D-EBD3-44E8-ABA9-BD5AAAA252E6}"/>
+                <a16:creationId xmlns:a16="http://schemas.microsoft.com/office/drawing/2014/main" id="{DE187B88-B881-4C33-808C-18017420D7F8}"/>
               </a:ext>
             </a:extLst>
           </p:cNvPr>
@@ -12922,7 +12922,7 @@
           <p:cNvPr id="8" name="">
             <a:extLst xmlns:a="http://schemas.openxmlformats.org/drawingml/2006/main">
               <a:ext uri="{FF2B5EF4-FFF2-40B4-BE49-F238E27FC236}">
-                <a16:creationId xmlns:a16="http://schemas.microsoft.com/office/drawing/2014/main" id="{D9A881CD-5902-4ED2-BDD6-958C569F23D6}"/>
+                <a16:creationId xmlns:a16="http://schemas.microsoft.com/office/drawing/2014/main" id="{7D65477F-1855-4BEA-B2A7-EB702DEFAF84}"/>
               </a:ext>
             </a:extLst>
           </p:cNvPr>
@@ -12983,7 +12983,7 @@
           <p:nvPr/>
         </p:nvPicPr>
         <p:blipFill>
-          <a:blip xmlns:r="http://schemas.openxmlformats.org/officeDocument/2006/relationships" xmlns:a="http://schemas.openxmlformats.org/drawingml/2006/main" r:embed="R92b1b18d9261445a"/>
+          <a:blip xmlns:r="http://schemas.openxmlformats.org/officeDocument/2006/relationships" xmlns:a="http://schemas.openxmlformats.org/drawingml/2006/main" r:embed="R6f1163db090246f0"/>
           <a:stretch xmlns:a="http://schemas.openxmlformats.org/drawingml/2006/main"/>
         </p:blipFill>
         <p:spPr>
@@ -13001,7 +13001,7 @@
           <p:cNvPr id="10" name="">
             <a:extLst xmlns:a="http://schemas.openxmlformats.org/drawingml/2006/main">
               <a:ext uri="{FF2B5EF4-FFF2-40B4-BE49-F238E27FC236}">
-                <a16:creationId xmlns:a16="http://schemas.microsoft.com/office/drawing/2014/main" id="{E6844126-1973-4D8F-8B75-F03F8F78BD01}"/>
+                <a16:creationId xmlns:a16="http://schemas.microsoft.com/office/drawing/2014/main" id="{B62DFF06-EE05-4059-A0B3-E4A42D9C6108}"/>
               </a:ext>
             </a:extLst>
           </p:cNvPr>
@@ -13056,7 +13056,7 @@
     </p:spTree>
     <p:extLst>
       <p:ext uri="{BB962C8B-B14F-4D97-AF65-F5344CB8AC3E}">
-        <p14:creationId xmlns:p14="http://schemas.microsoft.com/office/powerpoint/2010/main" val="1313516222"/>
+        <p14:creationId xmlns:p14="http://schemas.microsoft.com/office/powerpoint/2010/main" val="1718160149"/>
       </p:ext>
     </p:extLst>
   </p:cSld>
@@ -13087,7 +13087,7 @@
           <p:cNvPr id="3" name="Freeform 3">
             <a:extLst xmlns:a="http://schemas.openxmlformats.org/drawingml/2006/main">
               <a:ext uri="{FF2B5EF4-FFF2-40B4-BE49-F238E27FC236}">
-                <a16:creationId xmlns:a16="http://schemas.microsoft.com/office/drawing/2014/main" id="{8FABFE1F-4DA7-437F-AC08-3004B68CD30C}"/>
+                <a16:creationId xmlns:a16="http://schemas.microsoft.com/office/drawing/2014/main" id="{D664E72F-B355-44F9-946A-F67C05A97B00}"/>
               </a:ext>
             </a:extLst>
           </p:cNvPr>
@@ -13150,7 +13150,7 @@
           <p:cNvPr id="4" name="TextBox 4">
             <a:extLst xmlns:a="http://schemas.openxmlformats.org/drawingml/2006/main">
               <a:ext uri="{FF2B5EF4-FFF2-40B4-BE49-F238E27FC236}">
-                <a16:creationId xmlns:a16="http://schemas.microsoft.com/office/drawing/2014/main" id="{69FFFC62-D341-465D-895F-C996582127C7}"/>
+                <a16:creationId xmlns:a16="http://schemas.microsoft.com/office/drawing/2014/main" id="{6A06FFDB-93A0-445B-912C-7EC393B33546}"/>
               </a:ext>
             </a:extLst>
           </p:cNvPr>
@@ -13187,7 +13187,7 @@
           <p:cNvPr id="5" name="Freeform 5">
             <a:extLst xmlns:a="http://schemas.openxmlformats.org/drawingml/2006/main">
               <a:ext uri="{FF2B5EF4-FFF2-40B4-BE49-F238E27FC236}">
-                <a16:creationId xmlns:a16="http://schemas.microsoft.com/office/drawing/2014/main" id="{FABB99EF-7252-4FD9-885E-B251A7BA7045}"/>
+                <a16:creationId xmlns:a16="http://schemas.microsoft.com/office/drawing/2014/main" id="{7F644706-70C4-4D9E-8BBF-123503322CA1}"/>
               </a:ext>
             </a:extLst>
           </p:cNvPr>
@@ -13225,10 +13225,10 @@
             </a:pathLst>
           </a:custGeom>
           <a:blipFill xmlns:a="http://schemas.openxmlformats.org/drawingml/2006/main">
-            <a:blip xmlns:r="http://schemas.openxmlformats.org/officeDocument/2006/relationships" r:embed="Rdda8628c338147c3">
+            <a:blip xmlns:r="http://schemas.openxmlformats.org/officeDocument/2006/relationships" r:embed="R9fae4c1731164d0e">
               <a:extLst>
                 <a:ext uri="{96DAC541-7B7A-43D3-8B79-37D633B846F1}">
-                  <asvg:svgBlip xmlns:asvg="http://schemas.microsoft.com/office/drawing/2016/SVG/main" r:embed="R6505d1e509a44d63"/>
+                  <asvg:svgBlip xmlns:asvg="http://schemas.microsoft.com/office/drawing/2016/SVG/main" r:embed="R411a0a609fd84357"/>
                 </a:ext>
               </a:extLst>
             </a:blip>
@@ -13250,7 +13250,7 @@
           <p:cNvPr id="6" name="TextBox 6">
             <a:extLst xmlns:a="http://schemas.openxmlformats.org/drawingml/2006/main">
               <a:ext uri="{FF2B5EF4-FFF2-40B4-BE49-F238E27FC236}">
-                <a16:creationId xmlns:a16="http://schemas.microsoft.com/office/drawing/2014/main" id="{744C4F1D-D527-4202-9212-DA26138E5D0F}"/>
+                <a16:creationId xmlns:a16="http://schemas.microsoft.com/office/drawing/2014/main" id="{31EF852C-6F85-47BB-A675-2ED14ECD3EDF}"/>
               </a:ext>
             </a:extLst>
           </p:cNvPr>
@@ -13299,7 +13299,7 @@
           <p:cNvPr id="7" name="TextBox 7">
             <a:extLst xmlns:a="http://schemas.openxmlformats.org/drawingml/2006/main">
               <a:ext uri="{FF2B5EF4-FFF2-40B4-BE49-F238E27FC236}">
-                <a16:creationId xmlns:a16="http://schemas.microsoft.com/office/drawing/2014/main" id="{A4034D52-A52B-4CAD-ACA2-EAFB59A90D76}"/>
+                <a16:creationId xmlns:a16="http://schemas.microsoft.com/office/drawing/2014/main" id="{594C6423-EFF2-4451-9691-DC170F188198}"/>
               </a:ext>
             </a:extLst>
           </p:cNvPr>
@@ -13351,7 +13351,7 @@
           <p:cNvPr id="8" name="">
             <a:extLst xmlns:a="http://schemas.openxmlformats.org/drawingml/2006/main">
               <a:ext uri="{FF2B5EF4-FFF2-40B4-BE49-F238E27FC236}">
-                <a16:creationId xmlns:a16="http://schemas.microsoft.com/office/drawing/2014/main" id="{EE4520CE-A3FF-4584-97FB-98EAB7E26D86}"/>
+                <a16:creationId xmlns:a16="http://schemas.microsoft.com/office/drawing/2014/main" id="{5E5E732F-923F-4E69-9B57-0DCC3C48B897}"/>
               </a:ext>
             </a:extLst>
           </p:cNvPr>
@@ -13412,7 +13412,7 @@
           <p:nvPr/>
         </p:nvPicPr>
         <p:blipFill>
-          <a:blip xmlns:r="http://schemas.openxmlformats.org/officeDocument/2006/relationships" xmlns:a="http://schemas.openxmlformats.org/drawingml/2006/main" r:embed="R84268f6ba7354e9a"/>
+          <a:blip xmlns:r="http://schemas.openxmlformats.org/officeDocument/2006/relationships" xmlns:a="http://schemas.openxmlformats.org/drawingml/2006/main" r:embed="R17d1659c3b3e4f5c"/>
           <a:stretch xmlns:a="http://schemas.openxmlformats.org/drawingml/2006/main"/>
         </p:blipFill>
         <p:spPr>
@@ -13430,7 +13430,7 @@
           <p:cNvPr id="10" name="">
             <a:extLst xmlns:a="http://schemas.openxmlformats.org/drawingml/2006/main">
               <a:ext uri="{FF2B5EF4-FFF2-40B4-BE49-F238E27FC236}">
-                <a16:creationId xmlns:a16="http://schemas.microsoft.com/office/drawing/2014/main" id="{48AD03F1-6987-46A4-9265-12D631A200C0}"/>
+                <a16:creationId xmlns:a16="http://schemas.microsoft.com/office/drawing/2014/main" id="{D3C8DC2D-0EDB-4BE4-9330-BA5EA32B7267}"/>
               </a:ext>
             </a:extLst>
           </p:cNvPr>
@@ -13485,7 +13485,7 @@
     </p:spTree>
     <p:extLst>
       <p:ext uri="{BB962C8B-B14F-4D97-AF65-F5344CB8AC3E}">
-        <p14:creationId xmlns:p14="http://schemas.microsoft.com/office/powerpoint/2010/main" val="1715542065"/>
+        <p14:creationId xmlns:p14="http://schemas.microsoft.com/office/powerpoint/2010/main" val="645994921"/>
       </p:ext>
     </p:extLst>
   </p:cSld>

</xml_diff>